<commit_message>
Restyle File Conducteur + move interdiction notice to page background
File Conducteur: large fonts filling full slide, real logo on every slide,
yellow #D4A017 brand color, interdiction footer bar on all 7 slides.
Fiches PDF: interdiction notice moved to background bottom (z-index 0),
no longer a separate footer section — sits behind content.

https://claude.ai/code/session_019GY1Nt6aASgMoHXKsDdGTr
</commit_message>
<xml_diff>
--- a/FIM_Book0_FileConducteur.pptx
+++ b/FIM_Book0_FileConducteur.pptx
@@ -3109,7 +3109,7 @@
             <a:avLst/>
           </a:prstGeom>
           <a:solidFill>
-            <a:srgbClr val="F0F7F7"/>
+            <a:srgbClr val="008080"/>
           </a:solidFill>
           <a:ln>
             <a:noFill/>
@@ -3146,13 +3146,13 @@
         <p:spPr>
           <a:xfrm>
             <a:off x="0" y="0"/>
-            <a:ext cx="320040" cy="6858000"/>
+            <a:ext cx="12188952" cy="73152"/>
           </a:xfrm>
           <a:prstGeom prst="rect">
             <a:avLst/>
           </a:prstGeom>
           <a:solidFill>
-            <a:srgbClr val="008080"/>
+            <a:srgbClr val="D4A017"/>
           </a:solidFill>
           <a:ln>
             <a:noFill/>
@@ -3188,14 +3188,14 @@
         </p:nvSpPr>
         <p:spPr>
           <a:xfrm>
-            <a:off x="0" y="0"/>
-            <a:ext cx="12188952" cy="320040"/>
+            <a:off x="0" y="6784848"/>
+            <a:ext cx="12188952" cy="73152"/>
           </a:xfrm>
           <a:prstGeom prst="rect">
             <a:avLst/>
           </a:prstGeom>
           <a:solidFill>
-            <a:srgbClr val="008080"/>
+            <a:srgbClr val="D4A017"/>
           </a:solidFill>
           <a:ln>
             <a:noFill/>
@@ -3231,14 +3231,14 @@
         </p:nvSpPr>
         <p:spPr>
           <a:xfrm>
-            <a:off x="0" y="6400800"/>
-            <a:ext cx="12188952" cy="457200"/>
+            <a:off x="0" y="0"/>
+            <a:ext cx="73152" cy="6858000"/>
           </a:xfrm>
           <a:prstGeom prst="rect">
             <a:avLst/>
           </a:prstGeom>
           <a:solidFill>
-            <a:srgbClr val="008080"/>
+            <a:srgbClr val="D4A017"/>
           </a:solidFill>
           <a:ln>
             <a:noFill/>
@@ -3274,14 +3274,14 @@
         </p:nvSpPr>
         <p:spPr>
           <a:xfrm>
-            <a:off x="548640" y="914400"/>
-            <a:ext cx="2194560" cy="640080"/>
+            <a:off x="12115800" y="0"/>
+            <a:ext cx="73152" cy="6858000"/>
           </a:xfrm>
           <a:prstGeom prst="rect">
             <a:avLst/>
           </a:prstGeom>
           <a:solidFill>
-            <a:srgbClr val="008080"/>
+            <a:srgbClr val="D4A017"/>
           </a:solidFill>
           <a:ln>
             <a:noFill/>
@@ -3309,16 +3309,40 @@
           </a:p>
         </p:txBody>
       </p:sp>
-      <p:sp>
-        <p:nvSpPr>
-          <p:cNvPr id="7" name="TextBox 6"/>
+      <p:pic>
+        <p:nvPicPr>
+          <p:cNvPr id="7" name="Picture 6" descr="shy_logo.png"/>
+          <p:cNvPicPr>
+            <a:picLocks noChangeAspect="1"/>
+          </p:cNvPicPr>
+          <p:nvPr/>
+        </p:nvPicPr>
+        <p:blipFill>
+          <a:blip r:embed="rId2"/>
+          <a:stretch>
+            <a:fillRect/>
+          </a:stretch>
+        </p:blipFill>
+        <p:spPr>
+          <a:xfrm>
+            <a:off x="548640" y="320040"/>
+            <a:ext cx="3102429" cy="1371600"/>
+          </a:xfrm>
+          <a:prstGeom prst="rect">
+            <a:avLst/>
+          </a:prstGeom>
+        </p:spPr>
+      </p:pic>
+      <p:sp>
+        <p:nvSpPr>
+          <p:cNvPr id="8" name="TextBox 7"/>
           <p:cNvSpPr txBox="1"/>
           <p:nvPr/>
         </p:nvSpPr>
         <p:spPr>
           <a:xfrm>
-            <a:off x="594360" y="914400"/>
-            <a:ext cx="2103120" cy="640080"/>
+            <a:off x="457200" y="1920240"/>
+            <a:ext cx="11247120" cy="2011680"/>
           </a:xfrm>
           <a:prstGeom prst="rect">
             <a:avLst/>
@@ -3333,27 +3357,27 @@
           <a:p>
             <a:pPr algn="ctr"/>
             <a:r>
-              <a:rPr sz="1600" b="1" i="0">
+              <a:rPr sz="8000" b="1" i="0">
                 <a:solidFill>
                   <a:srgbClr val="FFFFFF"/>
                 </a:solidFill>
                 <a:latin typeface="Calibri"/>
               </a:rPr>
-              <a:t>KIT FIM</a:t>
-            </a:r>
-          </a:p>
-        </p:txBody>
-      </p:sp>
-      <p:sp>
-        <p:nvSpPr>
-          <p:cNvPr id="8" name="TextBox 7"/>
+              <a:t>FILE CONDUCTEUR</a:t>
+            </a:r>
+          </a:p>
+        </p:txBody>
+      </p:sp>
+      <p:sp>
+        <p:nvSpPr>
+          <p:cNvPr id="9" name="TextBox 8"/>
           <p:cNvSpPr txBox="1"/>
           <p:nvPr/>
         </p:nvSpPr>
         <p:spPr>
           <a:xfrm>
-            <a:off x="548640" y="411480"/>
-            <a:ext cx="4572000" cy="457200"/>
+            <a:off x="457200" y="3931920"/>
+            <a:ext cx="11247120" cy="731520"/>
           </a:xfrm>
           <a:prstGeom prst="rect">
             <a:avLst/>
@@ -3366,50 +3390,15 @@
           </a:bodyPr>
           <a:lstStyle/>
           <a:p>
-            <a:pPr algn="l"/>
-            <a:r>
-              <a:rPr sz="1300" b="1" i="0">
-                <a:solidFill>
-                  <a:srgbClr val="FFFFFF"/>
+            <a:pPr algn="ctr"/>
+            <a:r>
+              <a:rPr sz="2800" b="0" i="0">
+                <a:solidFill>
+                  <a:srgbClr val="D4A017"/>
                 </a:solidFill>
                 <a:latin typeface="Calibri"/>
               </a:rPr>
-              <a:t>SHY-Performance</a:t>
-            </a:r>
-          </a:p>
-        </p:txBody>
-      </p:sp>
-      <p:sp>
-        <p:nvSpPr>
-          <p:cNvPr id="9" name="TextBox 8"/>
-          <p:cNvSpPr txBox="1"/>
-          <p:nvPr/>
-        </p:nvSpPr>
-        <p:spPr>
-          <a:xfrm>
-            <a:off x="548640" y="1828800"/>
-            <a:ext cx="10515600" cy="1645920"/>
-          </a:xfrm>
-          <a:prstGeom prst="rect">
-            <a:avLst/>
-          </a:prstGeom>
-          <a:noFill/>
-        </p:spPr>
-        <p:txBody>
-          <a:bodyPr wrap="square">
-            <a:spAutoFit/>
-          </a:bodyPr>
-          <a:lstStyle/>
-          <a:p>
-            <a:pPr algn="l"/>
-            <a:r>
-              <a:rPr sz="4000" b="1" i="0">
-                <a:solidFill>
-                  <a:srgbClr val="008080"/>
-                </a:solidFill>
-                <a:latin typeface="Calibri"/>
-              </a:rPr>
-              <a:t>FILE CONDUCTEUR</a:t>
+              <a:t>KIT DE FORMATION INITIALE MODULE — FIM</a:t>
             </a:r>
           </a:p>
         </p:txBody>
@@ -3422,14 +3411,14 @@
         </p:nvSpPr>
         <p:spPr>
           <a:xfrm>
-            <a:off x="548640" y="3566160"/>
-            <a:ext cx="3657600" cy="54864"/>
+            <a:off x="1828800" y="4754880"/>
+            <a:ext cx="8531352" cy="45720"/>
           </a:xfrm>
           <a:prstGeom prst="rect">
             <a:avLst/>
           </a:prstGeom>
           <a:solidFill>
-            <a:srgbClr val="008080"/>
+            <a:srgbClr val="D4A017"/>
           </a:solidFill>
           <a:ln>
             <a:noFill/>
@@ -3465,8 +3454,8 @@
         </p:nvSpPr>
         <p:spPr>
           <a:xfrm>
-            <a:off x="548640" y="3749039"/>
-            <a:ext cx="10515600" cy="1097280"/>
+            <a:off x="457200" y="4892040"/>
+            <a:ext cx="11247120" cy="548640"/>
           </a:xfrm>
           <a:prstGeom prst="rect">
             <a:avLst/>
@@ -3479,16 +3468,15 @@
           </a:bodyPr>
           <a:lstStyle/>
           <a:p>
-            <a:pPr algn="l"/>
-            <a:r>
-              <a:rPr sz="1800" b="0" i="0">
-                <a:solidFill>
-                  <a:srgbClr val="1A1A1A"/>
+            <a:pPr algn="ctr"/>
+            <a:r>
+              <a:rPr sz="2000" b="0" i="0">
+                <a:solidFill>
+                  <a:srgbClr val="CCE5E5"/>
                 </a:solidFill>
                 <a:latin typeface="Calibri"/>
               </a:rPr>
-              <a:t>Guide d'utilisation du kit de formation FIM
-Formation Initiale Module — Fundraiser UNICEF</a:t>
+              <a:t>SHY-Performance  ×  FIDELIS  ×  UNICEF France</a:t>
             </a:r>
           </a:p>
         </p:txBody>
@@ -3501,8 +3489,8 @@
         </p:nvSpPr>
         <p:spPr>
           <a:xfrm>
-            <a:off x="548640" y="6446520"/>
-            <a:ext cx="9144000" cy="365760"/>
+            <a:off x="457200" y="5440680"/>
+            <a:ext cx="11247120" cy="457200"/>
           </a:xfrm>
           <a:prstGeom prst="rect">
             <a:avLst/>
@@ -3515,15 +3503,136 @@
           </a:bodyPr>
           <a:lstStyle/>
           <a:p>
-            <a:pPr algn="l"/>
-            <a:r>
-              <a:rPr sz="1100" b="0" i="0">
-                <a:solidFill>
-                  <a:srgbClr val="FFFFFF"/>
+            <a:pPr algn="ctr"/>
+            <a:r>
+              <a:rPr sz="1600" b="0" i="1">
+                <a:solidFill>
+                  <a:srgbClr val="CCE5E5"/>
                 </a:solidFill>
                 <a:latin typeface="Calibri"/>
               </a:rPr>
-              <a:t>FIDELIS  ×  UNICEF France  |  Formation Initiale Module</a:t>
+              <a:t>Fundraising · Formation · Performance</a:t>
+            </a:r>
+          </a:p>
+        </p:txBody>
+      </p:sp>
+      <p:sp>
+        <p:nvSpPr>
+          <p:cNvPr id="13" name="Rectangle 12"/>
+          <p:cNvSpPr/>
+          <p:nvPr/>
+        </p:nvSpPr>
+        <p:spPr>
+          <a:xfrm>
+            <a:off x="0" y="6309360"/>
+            <a:ext cx="12188952" cy="548640"/>
+          </a:xfrm>
+          <a:prstGeom prst="rect">
+            <a:avLst/>
+          </a:prstGeom>
+          <a:solidFill>
+            <a:srgbClr val="004D4D"/>
+          </a:solidFill>
+          <a:ln>
+            <a:noFill/>
+          </a:ln>
+        </p:spPr>
+        <p:style>
+          <a:lnRef idx="1">
+            <a:schemeClr val="accent1"/>
+          </a:lnRef>
+          <a:fillRef idx="3">
+            <a:schemeClr val="accent1"/>
+          </a:fillRef>
+          <a:effectRef idx="2">
+            <a:schemeClr val="accent1"/>
+          </a:effectRef>
+          <a:fontRef idx="minor">
+            <a:schemeClr val="lt1"/>
+          </a:fontRef>
+        </p:style>
+        <p:txBody>
+          <a:bodyPr rtlCol="0" anchor="ctr"/>
+          <a:lstStyle/>
+          <a:p>
+            <a:pPr algn="ctr"/>
+          </a:p>
+        </p:txBody>
+      </p:sp>
+      <p:sp>
+        <p:nvSpPr>
+          <p:cNvPr id="14" name="Rectangle 13"/>
+          <p:cNvSpPr/>
+          <p:nvPr/>
+        </p:nvSpPr>
+        <p:spPr>
+          <a:xfrm>
+            <a:off x="0" y="6309360"/>
+            <a:ext cx="12188952" cy="36576"/>
+          </a:xfrm>
+          <a:prstGeom prst="rect">
+            <a:avLst/>
+          </a:prstGeom>
+          <a:solidFill>
+            <a:srgbClr val="FF0000"/>
+          </a:solidFill>
+          <a:ln>
+            <a:noFill/>
+          </a:ln>
+        </p:spPr>
+        <p:style>
+          <a:lnRef idx="1">
+            <a:schemeClr val="accent1"/>
+          </a:lnRef>
+          <a:fillRef idx="3">
+            <a:schemeClr val="accent1"/>
+          </a:fillRef>
+          <a:effectRef idx="2">
+            <a:schemeClr val="accent1"/>
+          </a:effectRef>
+          <a:fontRef idx="minor">
+            <a:schemeClr val="lt1"/>
+          </a:fontRef>
+        </p:style>
+        <p:txBody>
+          <a:bodyPr rtlCol="0" anchor="ctr"/>
+          <a:lstStyle/>
+          <a:p>
+            <a:pPr algn="ctr"/>
+          </a:p>
+        </p:txBody>
+      </p:sp>
+      <p:sp>
+        <p:nvSpPr>
+          <p:cNvPr id="15" name="TextBox 14"/>
+          <p:cNvSpPr txBox="1"/>
+          <p:nvPr/>
+        </p:nvSpPr>
+        <p:spPr>
+          <a:xfrm>
+            <a:off x="182880" y="6327648"/>
+            <a:ext cx="11823192" cy="512064"/>
+          </a:xfrm>
+          <a:prstGeom prst="rect">
+            <a:avLst/>
+          </a:prstGeom>
+          <a:noFill/>
+        </p:spPr>
+        <p:txBody>
+          <a:bodyPr wrap="square">
+            <a:spAutoFit/>
+          </a:bodyPr>
+          <a:lstStyle/>
+          <a:p>
+            <a:pPr algn="ctr"/>
+            <a:r>
+              <a:rPr sz="800" b="0" i="0">
+                <a:solidFill>
+                  <a:srgbClr val="CCE5E5"/>
+                </a:solidFill>
+                <a:latin typeface="Calibri"/>
+              </a:rPr>
+              <a:t>⚠  DOCUMENT PROTÉGÉ — Toute modification, rectification ou ajout est STRICTEMENT INTERDIT. Seules la Direction Générale de SHY-Performance ou une personne expressément mandatée sont autorisées à modifier ce document.  Élaboré par Tamou Eljerrari — Ingénieur en Formation — Sur ordre de la Directrice Générale Mme Salima Negrao.</a:t>
             </a:r>
           </a:p>
         </p:txBody>
@@ -3555,7 +3664,50 @@
         <p:spPr>
           <a:xfrm>
             <a:off x="0" y="0"/>
-            <a:ext cx="12188952" cy="1280160"/>
+            <a:ext cx="12188952" cy="6858000"/>
+          </a:xfrm>
+          <a:prstGeom prst="rect">
+            <a:avLst/>
+          </a:prstGeom>
+          <a:solidFill>
+            <a:srgbClr val="F0F7F7"/>
+          </a:solidFill>
+          <a:ln>
+            <a:noFill/>
+          </a:ln>
+        </p:spPr>
+        <p:style>
+          <a:lnRef idx="1">
+            <a:schemeClr val="accent1"/>
+          </a:lnRef>
+          <a:fillRef idx="3">
+            <a:schemeClr val="accent1"/>
+          </a:fillRef>
+          <a:effectRef idx="2">
+            <a:schemeClr val="accent1"/>
+          </a:effectRef>
+          <a:fontRef idx="minor">
+            <a:schemeClr val="lt1"/>
+          </a:fontRef>
+        </p:style>
+        <p:txBody>
+          <a:bodyPr rtlCol="0" anchor="ctr"/>
+          <a:lstStyle/>
+          <a:p>
+            <a:pPr algn="ctr"/>
+          </a:p>
+        </p:txBody>
+      </p:sp>
+      <p:sp>
+        <p:nvSpPr>
+          <p:cNvPr id="3" name="Rectangle 2"/>
+          <p:cNvSpPr/>
+          <p:nvPr/>
+        </p:nvSpPr>
+        <p:spPr>
+          <a:xfrm>
+            <a:off x="0" y="0"/>
+            <a:ext cx="12188952" cy="1463040"/>
           </a:xfrm>
           <a:prstGeom prst="rect">
             <a:avLst/>
@@ -3589,22 +3741,46 @@
           </a:p>
         </p:txBody>
       </p:sp>
-      <p:sp>
-        <p:nvSpPr>
-          <p:cNvPr id="3" name="Rectangle 2"/>
+      <p:pic>
+        <p:nvPicPr>
+          <p:cNvPr id="4" name="Picture 3" descr="shy_logo.png"/>
+          <p:cNvPicPr>
+            <a:picLocks noChangeAspect="1"/>
+          </p:cNvPicPr>
+          <p:nvPr/>
+        </p:nvPicPr>
+        <p:blipFill>
+          <a:blip r:embed="rId2"/>
+          <a:stretch>
+            <a:fillRect/>
+          </a:stretch>
+        </p:blipFill>
+        <p:spPr>
+          <a:xfrm>
+            <a:off x="228600" y="182880"/>
+            <a:ext cx="2275114" cy="1005840"/>
+          </a:xfrm>
+          <a:prstGeom prst="rect">
+            <a:avLst/>
+          </a:prstGeom>
+        </p:spPr>
+      </p:pic>
+      <p:sp>
+        <p:nvSpPr>
+          <p:cNvPr id="5" name="Rectangle 4"/>
           <p:cNvSpPr/>
           <p:nvPr/>
         </p:nvSpPr>
         <p:spPr>
           <a:xfrm>
-            <a:off x="0" y="6492240"/>
-            <a:ext cx="12188952" cy="365760"/>
+            <a:off x="2651760" y="182880"/>
+            <a:ext cx="36576" cy="1097280"/>
           </a:xfrm>
           <a:prstGeom prst="rect">
             <a:avLst/>
           </a:prstGeom>
           <a:solidFill>
-            <a:srgbClr val="008080"/>
+            <a:srgbClr val="FFFFFF"/>
           </a:solidFill>
           <a:ln>
             <a:noFill/>
@@ -3634,14 +3810,14 @@
       </p:sp>
       <p:sp>
         <p:nvSpPr>
-          <p:cNvPr id="4" name="TextBox 3"/>
+          <p:cNvPr id="6" name="TextBox 5"/>
           <p:cNvSpPr txBox="1"/>
           <p:nvPr/>
         </p:nvSpPr>
         <p:spPr>
           <a:xfrm>
-            <a:off x="274320" y="137160"/>
-            <a:ext cx="914400" cy="1005840"/>
+            <a:off x="2834640" y="73152"/>
+            <a:ext cx="8961120" cy="914400"/>
           </a:xfrm>
           <a:prstGeom prst="rect">
             <a:avLst/>
@@ -3656,27 +3832,27 @@
           <a:p>
             <a:pPr algn="l"/>
             <a:r>
-              <a:rPr sz="4200" b="1" i="0">
+              <a:rPr sz="3800" b="1" i="0">
                 <a:solidFill>
                   <a:srgbClr val="FFFFFF"/>
                 </a:solidFill>
                 <a:latin typeface="Calibri"/>
               </a:rPr>
-              <a:t>01</a:t>
-            </a:r>
-          </a:p>
-        </p:txBody>
-      </p:sp>
-      <p:sp>
-        <p:nvSpPr>
-          <p:cNvPr id="5" name="TextBox 4"/>
+              <a:t>PRÉSENTATION DU KIT DE FORMATION</a:t>
+            </a:r>
+          </a:p>
+        </p:txBody>
+      </p:sp>
+      <p:sp>
+        <p:nvSpPr>
+          <p:cNvPr id="7" name="TextBox 6"/>
           <p:cNvSpPr txBox="1"/>
           <p:nvPr/>
         </p:nvSpPr>
         <p:spPr>
           <a:xfrm>
-            <a:off x="1280160" y="228600"/>
-            <a:ext cx="10058400" cy="822960"/>
+            <a:off x="2834640" y="914400"/>
+            <a:ext cx="8961120" cy="457200"/>
           </a:xfrm>
           <a:prstGeom prst="rect">
             <a:avLst/>
@@ -3691,27 +3867,27 @@
           <a:p>
             <a:pPr algn="l"/>
             <a:r>
-              <a:rPr sz="2600" b="1" i="0">
-                <a:solidFill>
-                  <a:srgbClr val="FFFFFF"/>
+              <a:rPr sz="1400" b="0" i="0">
+                <a:solidFill>
+                  <a:srgbClr val="CCE5E5"/>
                 </a:solidFill>
                 <a:latin typeface="Calibri"/>
               </a:rPr>
-              <a:t>Présentation du Kit de Formation</a:t>
-            </a:r>
-          </a:p>
-        </p:txBody>
-      </p:sp>
-      <p:sp>
-        <p:nvSpPr>
-          <p:cNvPr id="6" name="TextBox 5"/>
+              <a:t>7 documents — Une formation complète de A à Z</a:t>
+            </a:r>
+          </a:p>
+        </p:txBody>
+      </p:sp>
+      <p:sp>
+        <p:nvSpPr>
+          <p:cNvPr id="8" name="TextBox 7"/>
           <p:cNvSpPr txBox="1"/>
           <p:nvPr/>
         </p:nvSpPr>
         <p:spPr>
           <a:xfrm>
-            <a:off x="457200" y="1463040"/>
-            <a:ext cx="11247120" cy="5486400"/>
+            <a:off x="365760" y="1600200"/>
+            <a:ext cx="11430000" cy="4663440"/>
           </a:xfrm>
           <a:prstGeom prst="rect">
             <a:avLst/>
@@ -3726,143 +3902,213 @@
           <a:p>
             <a:pPr>
               <a:spcBef>
-                <a:spcPts val="400"/>
+                <a:spcPts val="600"/>
               </a:spcBef>
             </a:pPr>
             <a:r>
-              <a:rPr sz="1500">
+              <a:rPr sz="2200">
                 <a:solidFill>
                   <a:srgbClr val="1A1A1A"/>
                 </a:solidFill>
                 <a:latin typeface="Calibri"/>
               </a:rPr>
-              <a:t>▸ 7 documents composent ce kit de formation complet</a:t>
+              <a:t>▸  Book 0 — File Conducteur (ce document) : guide d'utilisation globale du kit</a:t>
             </a:r>
           </a:p>
           <a:p>
             <a:pPr>
               <a:spcBef>
-                <a:spcPts val="400"/>
+                <a:spcPts val="600"/>
               </a:spcBef>
             </a:pPr>
             <a:r>
-              <a:rPr sz="1500">
+              <a:rPr sz="2200">
                 <a:solidFill>
                   <a:srgbClr val="1A1A1A"/>
                 </a:solidFill>
                 <a:latin typeface="Calibri"/>
               </a:rPr>
-              <a:t>▸ Book 0 — File Conducteur (ce document) : guide d'utilisation globale</a:t>
+              <a:t>▸  Book 1 — Synopsis &amp; Objectifs Pédagogiques : cadre, vision et objectifs de la formation</a:t>
             </a:r>
           </a:p>
           <a:p>
             <a:pPr>
               <a:spcBef>
-                <a:spcPts val="400"/>
+                <a:spcPts val="600"/>
               </a:spcBef>
             </a:pPr>
             <a:r>
-              <a:rPr sz="1500">
+              <a:rPr sz="2200">
                 <a:solidFill>
                   <a:srgbClr val="1A1A1A"/>
                 </a:solidFill>
                 <a:latin typeface="Calibri"/>
               </a:rPr>
-              <a:t>▸ Book 1 — Synopsis &amp; Objectifs Pédagogiques : cadre et vision de la formation</a:t>
+              <a:t>▸  Book J1 — Fondations &amp; Mission : KPIs, nomenclature, script d'accroche</a:t>
             </a:r>
           </a:p>
           <a:p>
             <a:pPr>
               <a:spcBef>
-                <a:spcPts val="400"/>
+                <a:spcPts val="600"/>
               </a:spcBef>
             </a:pPr>
             <a:r>
-              <a:rPr sz="1500">
+              <a:rPr sz="2200">
                 <a:solidFill>
                   <a:srgbClr val="1A1A1A"/>
                 </a:solidFill>
                 <a:latin typeface="Calibri"/>
               </a:rPr>
-              <a:t>▸ Book J1 — Fondations &amp; Mission : KPIs, nomenclature, script accroche</a:t>
+              <a:t>▸  Book J2 — Monde Associatif &amp; Humanitaire : contexte, Loi 1901, histoire UNICEF</a:t>
             </a:r>
           </a:p>
           <a:p>
             <a:pPr>
               <a:spcBef>
-                <a:spcPts val="400"/>
+                <a:spcPts val="600"/>
               </a:spcBef>
             </a:pPr>
             <a:r>
-              <a:rPr sz="1500">
+              <a:rPr sz="2200">
                 <a:solidFill>
                   <a:srgbClr val="1A1A1A"/>
                 </a:solidFill>
                 <a:latin typeface="Calibri"/>
               </a:rPr>
-              <a:t>▸ Book J2 — Monde Associatif &amp; Humanitaire : contexte, loi 1901, UNICEF</a:t>
+              <a:t>▸  Book J3 — Analyse et Lecture du Script : décryptage phrase par phrase, exercices</a:t>
             </a:r>
           </a:p>
           <a:p>
             <a:pPr>
               <a:spcBef>
-                <a:spcPts val="400"/>
+                <a:spcPts val="600"/>
               </a:spcBef>
             </a:pPr>
             <a:r>
-              <a:rPr sz="1500">
+              <a:rPr sz="2200">
                 <a:solidFill>
                   <a:srgbClr val="1A1A1A"/>
                 </a:solidFill>
                 <a:latin typeface="Calibri"/>
               </a:rPr>
-              <a:t>▸ Book J3 — Analyse et Lecture du Script : décryptage phrase par phrase</a:t>
+              <a:t>▸  Book J4 — Traitement des Objections : 15 objections, méthode AAR, jeux de rôle</a:t>
             </a:r>
           </a:p>
           <a:p>
             <a:pPr>
               <a:spcBef>
-                <a:spcPts val="400"/>
+                <a:spcPts val="600"/>
               </a:spcBef>
             </a:pPr>
             <a:r>
-              <a:rPr sz="1500">
+              <a:rPr sz="2200">
                 <a:solidFill>
                   <a:srgbClr val="1A1A1A"/>
                 </a:solidFill>
                 <a:latin typeface="Calibri"/>
               </a:rPr>
-              <a:t>▸ Book J4 — Traitement des Objections : 15 objections, méthode AAR</a:t>
-            </a:r>
-          </a:p>
-          <a:p>
-            <a:pPr>
-              <a:spcBef>
-                <a:spcPts val="400"/>
-              </a:spcBef>
-            </a:pPr>
-            <a:r>
-              <a:rPr sz="1500">
-                <a:solidFill>
-                  <a:srgbClr val="1A1A1A"/>
-                </a:solidFill>
-                <a:latin typeface="Calibri"/>
-              </a:rPr>
-              <a:t>▸ Book J5 — Synthèse Générale &amp; Simulations : évaluation finale, quiz 40Q</a:t>
-            </a:r>
-          </a:p>
-        </p:txBody>
-      </p:sp>
-      <p:sp>
-        <p:nvSpPr>
-          <p:cNvPr id="7" name="TextBox 6"/>
+              <a:t>▸  Book J5 — Synthèse Générale &amp; Simulations : révision, quiz 40Q, certifications</a:t>
+            </a:r>
+          </a:p>
+        </p:txBody>
+      </p:sp>
+      <p:sp>
+        <p:nvSpPr>
+          <p:cNvPr id="9" name="Rectangle 8"/>
+          <p:cNvSpPr/>
+          <p:nvPr/>
+        </p:nvSpPr>
+        <p:spPr>
+          <a:xfrm>
+            <a:off x="0" y="6309360"/>
+            <a:ext cx="12188952" cy="548640"/>
+          </a:xfrm>
+          <a:prstGeom prst="rect">
+            <a:avLst/>
+          </a:prstGeom>
+          <a:solidFill>
+            <a:srgbClr val="004D4D"/>
+          </a:solidFill>
+          <a:ln>
+            <a:noFill/>
+          </a:ln>
+        </p:spPr>
+        <p:style>
+          <a:lnRef idx="1">
+            <a:schemeClr val="accent1"/>
+          </a:lnRef>
+          <a:fillRef idx="3">
+            <a:schemeClr val="accent1"/>
+          </a:fillRef>
+          <a:effectRef idx="2">
+            <a:schemeClr val="accent1"/>
+          </a:effectRef>
+          <a:fontRef idx="minor">
+            <a:schemeClr val="lt1"/>
+          </a:fontRef>
+        </p:style>
+        <p:txBody>
+          <a:bodyPr rtlCol="0" anchor="ctr"/>
+          <a:lstStyle/>
+          <a:p>
+            <a:pPr algn="ctr"/>
+          </a:p>
+        </p:txBody>
+      </p:sp>
+      <p:sp>
+        <p:nvSpPr>
+          <p:cNvPr id="10" name="Rectangle 9"/>
+          <p:cNvSpPr/>
+          <p:nvPr/>
+        </p:nvSpPr>
+        <p:spPr>
+          <a:xfrm>
+            <a:off x="0" y="6309360"/>
+            <a:ext cx="12188952" cy="36576"/>
+          </a:xfrm>
+          <a:prstGeom prst="rect">
+            <a:avLst/>
+          </a:prstGeom>
+          <a:solidFill>
+            <a:srgbClr val="FF0000"/>
+          </a:solidFill>
+          <a:ln>
+            <a:noFill/>
+          </a:ln>
+        </p:spPr>
+        <p:style>
+          <a:lnRef idx="1">
+            <a:schemeClr val="accent1"/>
+          </a:lnRef>
+          <a:fillRef idx="3">
+            <a:schemeClr val="accent1"/>
+          </a:fillRef>
+          <a:effectRef idx="2">
+            <a:schemeClr val="accent1"/>
+          </a:effectRef>
+          <a:fontRef idx="minor">
+            <a:schemeClr val="lt1"/>
+          </a:fontRef>
+        </p:style>
+        <p:txBody>
+          <a:bodyPr rtlCol="0" anchor="ctr"/>
+          <a:lstStyle/>
+          <a:p>
+            <a:pPr algn="ctr"/>
+          </a:p>
+        </p:txBody>
+      </p:sp>
+      <p:sp>
+        <p:nvSpPr>
+          <p:cNvPr id="11" name="TextBox 10"/>
           <p:cNvSpPr txBox="1"/>
           <p:nvPr/>
         </p:nvSpPr>
         <p:spPr>
           <a:xfrm>
-            <a:off x="274320" y="6519672"/>
-            <a:ext cx="9144000" cy="320040"/>
+            <a:off x="182880" y="6327648"/>
+            <a:ext cx="11823192" cy="512064"/>
           </a:xfrm>
           <a:prstGeom prst="rect">
             <a:avLst/>
@@ -3875,15 +4121,15 @@
           </a:bodyPr>
           <a:lstStyle/>
           <a:p>
-            <a:pPr algn="l"/>
-            <a:r>
-              <a:rPr sz="1000" b="0" i="0">
-                <a:solidFill>
-                  <a:srgbClr val="FFFFFF"/>
+            <a:pPr algn="ctr"/>
+            <a:r>
+              <a:rPr sz="800" b="0" i="0">
+                <a:solidFill>
+                  <a:srgbClr val="CCE5E5"/>
                 </a:solidFill>
                 <a:latin typeface="Calibri"/>
               </a:rPr>
-              <a:t>SHY-Performance  ×  FIDELIS  ×  UNICEF France</a:t>
+              <a:t>⚠  DOCUMENT PROTÉGÉ — Toute modification, rectification ou ajout est STRICTEMENT INTERDIT. Seules la Direction Générale de SHY-Performance ou une personne expressément mandatée sont autorisées à modifier ce document.  Élaboré par Tamou Eljerrari — Ingénieur en Formation — Sur ordre de la Directrice Générale Mme Salima Negrao.</a:t>
             </a:r>
           </a:p>
         </p:txBody>
@@ -3915,7 +4161,50 @@
         <p:spPr>
           <a:xfrm>
             <a:off x="0" y="0"/>
-            <a:ext cx="12188952" cy="1280160"/>
+            <a:ext cx="12188952" cy="6858000"/>
+          </a:xfrm>
+          <a:prstGeom prst="rect">
+            <a:avLst/>
+          </a:prstGeom>
+          <a:solidFill>
+            <a:srgbClr val="F0F7F7"/>
+          </a:solidFill>
+          <a:ln>
+            <a:noFill/>
+          </a:ln>
+        </p:spPr>
+        <p:style>
+          <a:lnRef idx="1">
+            <a:schemeClr val="accent1"/>
+          </a:lnRef>
+          <a:fillRef idx="3">
+            <a:schemeClr val="accent1"/>
+          </a:fillRef>
+          <a:effectRef idx="2">
+            <a:schemeClr val="accent1"/>
+          </a:effectRef>
+          <a:fontRef idx="minor">
+            <a:schemeClr val="lt1"/>
+          </a:fontRef>
+        </p:style>
+        <p:txBody>
+          <a:bodyPr rtlCol="0" anchor="ctr"/>
+          <a:lstStyle/>
+          <a:p>
+            <a:pPr algn="ctr"/>
+          </a:p>
+        </p:txBody>
+      </p:sp>
+      <p:sp>
+        <p:nvSpPr>
+          <p:cNvPr id="3" name="Rectangle 2"/>
+          <p:cNvSpPr/>
+          <p:nvPr/>
+        </p:nvSpPr>
+        <p:spPr>
+          <a:xfrm>
+            <a:off x="0" y="0"/>
+            <a:ext cx="12188952" cy="1463040"/>
           </a:xfrm>
           <a:prstGeom prst="rect">
             <a:avLst/>
@@ -3949,22 +4238,46 @@
           </a:p>
         </p:txBody>
       </p:sp>
-      <p:sp>
-        <p:nvSpPr>
-          <p:cNvPr id="3" name="Rectangle 2"/>
+      <p:pic>
+        <p:nvPicPr>
+          <p:cNvPr id="4" name="Picture 3" descr="shy_logo.png"/>
+          <p:cNvPicPr>
+            <a:picLocks noChangeAspect="1"/>
+          </p:cNvPicPr>
+          <p:nvPr/>
+        </p:nvPicPr>
+        <p:blipFill>
+          <a:blip r:embed="rId2"/>
+          <a:stretch>
+            <a:fillRect/>
+          </a:stretch>
+        </p:blipFill>
+        <p:spPr>
+          <a:xfrm>
+            <a:off x="228600" y="182880"/>
+            <a:ext cx="2275114" cy="1005840"/>
+          </a:xfrm>
+          <a:prstGeom prst="rect">
+            <a:avLst/>
+          </a:prstGeom>
+        </p:spPr>
+      </p:pic>
+      <p:sp>
+        <p:nvSpPr>
+          <p:cNvPr id="5" name="Rectangle 4"/>
           <p:cNvSpPr/>
           <p:nvPr/>
         </p:nvSpPr>
         <p:spPr>
           <a:xfrm>
-            <a:off x="0" y="6492240"/>
-            <a:ext cx="12188952" cy="365760"/>
+            <a:off x="2651760" y="182880"/>
+            <a:ext cx="36576" cy="1097280"/>
           </a:xfrm>
           <a:prstGeom prst="rect">
             <a:avLst/>
           </a:prstGeom>
           <a:solidFill>
-            <a:srgbClr val="008080"/>
+            <a:srgbClr val="FFFFFF"/>
           </a:solidFill>
           <a:ln>
             <a:noFill/>
@@ -3994,14 +4307,14 @@
       </p:sp>
       <p:sp>
         <p:nvSpPr>
-          <p:cNvPr id="4" name="TextBox 3"/>
+          <p:cNvPr id="6" name="TextBox 5"/>
           <p:cNvSpPr txBox="1"/>
           <p:nvPr/>
         </p:nvSpPr>
         <p:spPr>
           <a:xfrm>
-            <a:off x="274320" y="137160"/>
-            <a:ext cx="914400" cy="1005840"/>
+            <a:off x="2834640" y="73152"/>
+            <a:ext cx="8961120" cy="914400"/>
           </a:xfrm>
           <a:prstGeom prst="rect">
             <a:avLst/>
@@ -4016,27 +4329,27 @@
           <a:p>
             <a:pPr algn="l"/>
             <a:r>
-              <a:rPr sz="4200" b="1" i="0">
+              <a:rPr sz="3800" b="1" i="0">
                 <a:solidFill>
                   <a:srgbClr val="FFFFFF"/>
                 </a:solidFill>
                 <a:latin typeface="Calibri"/>
               </a:rPr>
-              <a:t>02</a:t>
-            </a:r>
-          </a:p>
-        </p:txBody>
-      </p:sp>
-      <p:sp>
-        <p:nvSpPr>
-          <p:cNvPr id="5" name="TextBox 4"/>
+              <a:t>QUI FORME ? QUI EST FORMÉ ?</a:t>
+            </a:r>
+          </a:p>
+        </p:txBody>
+      </p:sp>
+      <p:sp>
+        <p:nvSpPr>
+          <p:cNvPr id="7" name="TextBox 6"/>
           <p:cNvSpPr txBox="1"/>
           <p:nvPr/>
         </p:nvSpPr>
         <p:spPr>
           <a:xfrm>
-            <a:off x="1280160" y="228600"/>
-            <a:ext cx="10058400" cy="822960"/>
+            <a:off x="2834640" y="914400"/>
+            <a:ext cx="8961120" cy="457200"/>
           </a:xfrm>
           <a:prstGeom prst="rect">
             <a:avLst/>
@@ -4051,27 +4364,27 @@
           <a:p>
             <a:pPr algn="l"/>
             <a:r>
-              <a:rPr sz="2600" b="1" i="0">
-                <a:solidFill>
-                  <a:srgbClr val="FFFFFF"/>
+              <a:rPr sz="1400" b="0" i="0">
+                <a:solidFill>
+                  <a:srgbClr val="CCE5E5"/>
                 </a:solidFill>
                 <a:latin typeface="Calibri"/>
               </a:rPr>
-              <a:t>Qui forme ? Qui est formé ?</a:t>
-            </a:r>
-          </a:p>
-        </p:txBody>
-      </p:sp>
-      <p:sp>
-        <p:nvSpPr>
-          <p:cNvPr id="6" name="TextBox 5"/>
+              <a:t>Acteurs et public cible de la formation FIM</a:t>
+            </a:r>
+          </a:p>
+        </p:txBody>
+      </p:sp>
+      <p:sp>
+        <p:nvSpPr>
+          <p:cNvPr id="8" name="TextBox 7"/>
           <p:cNvSpPr txBox="1"/>
           <p:nvPr/>
         </p:nvSpPr>
         <p:spPr>
           <a:xfrm>
-            <a:off x="457200" y="1463040"/>
-            <a:ext cx="11247120" cy="5486400"/>
+            <a:off x="365760" y="1600200"/>
+            <a:ext cx="11430000" cy="4663440"/>
           </a:xfrm>
           <a:prstGeom prst="rect">
             <a:avLst/>
@@ -4086,111 +4399,197 @@
           <a:p>
             <a:pPr>
               <a:spcBef>
-                <a:spcPts val="400"/>
+                <a:spcPts val="600"/>
               </a:spcBef>
             </a:pPr>
             <a:r>
-              <a:rPr sz="1500">
+              <a:rPr sz="2200">
                 <a:solidFill>
                   <a:srgbClr val="1A1A1A"/>
                 </a:solidFill>
                 <a:latin typeface="Calibri"/>
               </a:rPr>
-              <a:t>▸ Donneur d'ordre : FIDELIS — mandataire officiel de la campagne UNICEF</a:t>
+              <a:t>▸  Donneur d'ordre : FIDELIS — mandataire officiel de la campagne UNICEF</a:t>
             </a:r>
           </a:p>
           <a:p>
             <a:pPr>
               <a:spcBef>
-                <a:spcPts val="400"/>
+                <a:spcPts val="600"/>
               </a:spcBef>
             </a:pPr>
             <a:r>
-              <a:rPr sz="1500">
+              <a:rPr sz="2200">
                 <a:solidFill>
                   <a:srgbClr val="1A1A1A"/>
                 </a:solidFill>
                 <a:latin typeface="Calibri"/>
               </a:rPr>
-              <a:t>▸ Opérateur terrain : SHY-Performance — centre de collecte téléphonique</a:t>
+              <a:t>▸  Opérateur terrain : SHY-Performance — centre de collecte téléphonique de référence</a:t>
             </a:r>
           </a:p>
           <a:p>
             <a:pPr>
               <a:spcBef>
-                <a:spcPts val="400"/>
+                <a:spcPts val="600"/>
               </a:spcBef>
             </a:pPr>
             <a:r>
-              <a:rPr sz="1500">
+              <a:rPr sz="2200">
                 <a:solidFill>
                   <a:srgbClr val="1A1A1A"/>
                 </a:solidFill>
                 <a:latin typeface="Calibri"/>
               </a:rPr>
-              <a:t>▸ Public cible : fundraisers SHY-Performance, nouveaux entrants en collecte de dons</a:t>
+              <a:t>▸  Public cible : fundraisers SHY-Performance — nouveaux entrants en collecte de dons</a:t>
             </a:r>
           </a:p>
           <a:p>
             <a:pPr>
               <a:spcBef>
-                <a:spcPts val="400"/>
+                <a:spcPts val="600"/>
               </a:spcBef>
             </a:pPr>
             <a:r>
-              <a:rPr sz="1500">
+              <a:rPr sz="2200">
                 <a:solidFill>
                   <a:srgbClr val="1A1A1A"/>
                 </a:solidFill>
                 <a:latin typeface="Calibri"/>
               </a:rPr>
-              <a:t>▸ Prérequis : aucune expérience préalable en collecte de dons requise</a:t>
+              <a:t>▸  Prérequis : aucune expérience préalable en collecte de dons requise</a:t>
             </a:r>
           </a:p>
           <a:p>
             <a:pPr>
               <a:spcBef>
-                <a:spcPts val="400"/>
+                <a:spcPts val="600"/>
               </a:spcBef>
             </a:pPr>
             <a:r>
-              <a:rPr sz="1500">
+              <a:rPr sz="2200">
                 <a:solidFill>
                   <a:srgbClr val="1A1A1A"/>
                 </a:solidFill>
                 <a:latin typeface="Calibri"/>
               </a:rPr>
-              <a:t>▸ Effectif recommandé : 8 à 14 fundraisers par session</a:t>
+              <a:t>▸  Effectif recommandé par session : 8 à 14 fundraisers pour garantir la qualité des JDR</a:t>
             </a:r>
           </a:p>
           <a:p>
             <a:pPr>
               <a:spcBef>
-                <a:spcPts val="400"/>
+                <a:spcPts val="600"/>
               </a:spcBef>
             </a:pPr>
             <a:r>
-              <a:rPr sz="1500">
+              <a:rPr sz="2200">
                 <a:solidFill>
                   <a:srgbClr val="1A1A1A"/>
                 </a:solidFill>
                 <a:latin typeface="Calibri"/>
               </a:rPr>
-              <a:t>▸ Durée totale : 5 jours consécutifs | 9h30–17h30 | 6h40 de production effective/jour</a:t>
-            </a:r>
-          </a:p>
-        </p:txBody>
-      </p:sp>
-      <p:sp>
-        <p:nvSpPr>
-          <p:cNvPr id="7" name="TextBox 6"/>
+              <a:t>▸  Durée totale : 5 jours consécutifs | 9h30–17h30 | 6h40 de production effective/jour</a:t>
+            </a:r>
+          </a:p>
+        </p:txBody>
+      </p:sp>
+      <p:sp>
+        <p:nvSpPr>
+          <p:cNvPr id="9" name="Rectangle 8"/>
+          <p:cNvSpPr/>
+          <p:nvPr/>
+        </p:nvSpPr>
+        <p:spPr>
+          <a:xfrm>
+            <a:off x="0" y="6309360"/>
+            <a:ext cx="12188952" cy="548640"/>
+          </a:xfrm>
+          <a:prstGeom prst="rect">
+            <a:avLst/>
+          </a:prstGeom>
+          <a:solidFill>
+            <a:srgbClr val="004D4D"/>
+          </a:solidFill>
+          <a:ln>
+            <a:noFill/>
+          </a:ln>
+        </p:spPr>
+        <p:style>
+          <a:lnRef idx="1">
+            <a:schemeClr val="accent1"/>
+          </a:lnRef>
+          <a:fillRef idx="3">
+            <a:schemeClr val="accent1"/>
+          </a:fillRef>
+          <a:effectRef idx="2">
+            <a:schemeClr val="accent1"/>
+          </a:effectRef>
+          <a:fontRef idx="minor">
+            <a:schemeClr val="lt1"/>
+          </a:fontRef>
+        </p:style>
+        <p:txBody>
+          <a:bodyPr rtlCol="0" anchor="ctr"/>
+          <a:lstStyle/>
+          <a:p>
+            <a:pPr algn="ctr"/>
+          </a:p>
+        </p:txBody>
+      </p:sp>
+      <p:sp>
+        <p:nvSpPr>
+          <p:cNvPr id="10" name="Rectangle 9"/>
+          <p:cNvSpPr/>
+          <p:nvPr/>
+        </p:nvSpPr>
+        <p:spPr>
+          <a:xfrm>
+            <a:off x="0" y="6309360"/>
+            <a:ext cx="12188952" cy="36576"/>
+          </a:xfrm>
+          <a:prstGeom prst="rect">
+            <a:avLst/>
+          </a:prstGeom>
+          <a:solidFill>
+            <a:srgbClr val="FF0000"/>
+          </a:solidFill>
+          <a:ln>
+            <a:noFill/>
+          </a:ln>
+        </p:spPr>
+        <p:style>
+          <a:lnRef idx="1">
+            <a:schemeClr val="accent1"/>
+          </a:lnRef>
+          <a:fillRef idx="3">
+            <a:schemeClr val="accent1"/>
+          </a:fillRef>
+          <a:effectRef idx="2">
+            <a:schemeClr val="accent1"/>
+          </a:effectRef>
+          <a:fontRef idx="minor">
+            <a:schemeClr val="lt1"/>
+          </a:fontRef>
+        </p:style>
+        <p:txBody>
+          <a:bodyPr rtlCol="0" anchor="ctr"/>
+          <a:lstStyle/>
+          <a:p>
+            <a:pPr algn="ctr"/>
+          </a:p>
+        </p:txBody>
+      </p:sp>
+      <p:sp>
+        <p:nvSpPr>
+          <p:cNvPr id="11" name="TextBox 10"/>
           <p:cNvSpPr txBox="1"/>
           <p:nvPr/>
         </p:nvSpPr>
         <p:spPr>
           <a:xfrm>
-            <a:off x="274320" y="6519672"/>
-            <a:ext cx="9144000" cy="320040"/>
+            <a:off x="182880" y="6327648"/>
+            <a:ext cx="11823192" cy="512064"/>
           </a:xfrm>
           <a:prstGeom prst="rect">
             <a:avLst/>
@@ -4203,15 +4602,15 @@
           </a:bodyPr>
           <a:lstStyle/>
           <a:p>
-            <a:pPr algn="l"/>
-            <a:r>
-              <a:rPr sz="1000" b="0" i="0">
-                <a:solidFill>
-                  <a:srgbClr val="FFFFFF"/>
+            <a:pPr algn="ctr"/>
+            <a:r>
+              <a:rPr sz="800" b="0" i="0">
+                <a:solidFill>
+                  <a:srgbClr val="CCE5E5"/>
                 </a:solidFill>
                 <a:latin typeface="Calibri"/>
               </a:rPr>
-              <a:t>SHY-Performance  ×  FIDELIS  ×  UNICEF France</a:t>
+              <a:t>⚠  DOCUMENT PROTÉGÉ — Toute modification, rectification ou ajout est STRICTEMENT INTERDIT. Seules la Direction Générale de SHY-Performance ou une personne expressément mandatée sont autorisées à modifier ce document.  Élaboré par Tamou Eljerrari — Ingénieur en Formation — Sur ordre de la Directrice Générale Mme Salima Negrao.</a:t>
             </a:r>
           </a:p>
         </p:txBody>
@@ -4243,7 +4642,50 @@
         <p:spPr>
           <a:xfrm>
             <a:off x="0" y="0"/>
-            <a:ext cx="12188952" cy="1280160"/>
+            <a:ext cx="12188952" cy="6858000"/>
+          </a:xfrm>
+          <a:prstGeom prst="rect">
+            <a:avLst/>
+          </a:prstGeom>
+          <a:solidFill>
+            <a:srgbClr val="F0F7F7"/>
+          </a:solidFill>
+          <a:ln>
+            <a:noFill/>
+          </a:ln>
+        </p:spPr>
+        <p:style>
+          <a:lnRef idx="1">
+            <a:schemeClr val="accent1"/>
+          </a:lnRef>
+          <a:fillRef idx="3">
+            <a:schemeClr val="accent1"/>
+          </a:fillRef>
+          <a:effectRef idx="2">
+            <a:schemeClr val="accent1"/>
+          </a:effectRef>
+          <a:fontRef idx="minor">
+            <a:schemeClr val="lt1"/>
+          </a:fontRef>
+        </p:style>
+        <p:txBody>
+          <a:bodyPr rtlCol="0" anchor="ctr"/>
+          <a:lstStyle/>
+          <a:p>
+            <a:pPr algn="ctr"/>
+          </a:p>
+        </p:txBody>
+      </p:sp>
+      <p:sp>
+        <p:nvSpPr>
+          <p:cNvPr id="3" name="Rectangle 2"/>
+          <p:cNvSpPr/>
+          <p:nvPr/>
+        </p:nvSpPr>
+        <p:spPr>
+          <a:xfrm>
+            <a:off x="0" y="0"/>
+            <a:ext cx="12188952" cy="1463040"/>
           </a:xfrm>
           <a:prstGeom prst="rect">
             <a:avLst/>
@@ -4277,22 +4719,46 @@
           </a:p>
         </p:txBody>
       </p:sp>
-      <p:sp>
-        <p:nvSpPr>
-          <p:cNvPr id="3" name="Rectangle 2"/>
+      <p:pic>
+        <p:nvPicPr>
+          <p:cNvPr id="4" name="Picture 3" descr="shy_logo.png"/>
+          <p:cNvPicPr>
+            <a:picLocks noChangeAspect="1"/>
+          </p:cNvPicPr>
+          <p:nvPr/>
+        </p:nvPicPr>
+        <p:blipFill>
+          <a:blip r:embed="rId2"/>
+          <a:stretch>
+            <a:fillRect/>
+          </a:stretch>
+        </p:blipFill>
+        <p:spPr>
+          <a:xfrm>
+            <a:off x="228600" y="182880"/>
+            <a:ext cx="2275114" cy="1005840"/>
+          </a:xfrm>
+          <a:prstGeom prst="rect">
+            <a:avLst/>
+          </a:prstGeom>
+        </p:spPr>
+      </p:pic>
+      <p:sp>
+        <p:nvSpPr>
+          <p:cNvPr id="5" name="Rectangle 4"/>
           <p:cNvSpPr/>
           <p:nvPr/>
         </p:nvSpPr>
         <p:spPr>
           <a:xfrm>
-            <a:off x="0" y="6492240"/>
-            <a:ext cx="12188952" cy="365760"/>
+            <a:off x="2651760" y="182880"/>
+            <a:ext cx="36576" cy="1097280"/>
           </a:xfrm>
           <a:prstGeom prst="rect">
             <a:avLst/>
           </a:prstGeom>
           <a:solidFill>
-            <a:srgbClr val="008080"/>
+            <a:srgbClr val="FFFFFF"/>
           </a:solidFill>
           <a:ln>
             <a:noFill/>
@@ -4322,14 +4788,14 @@
       </p:sp>
       <p:sp>
         <p:nvSpPr>
-          <p:cNvPr id="4" name="TextBox 3"/>
+          <p:cNvPr id="6" name="TextBox 5"/>
           <p:cNvSpPr txBox="1"/>
           <p:nvPr/>
         </p:nvSpPr>
         <p:spPr>
           <a:xfrm>
-            <a:off x="274320" y="137160"/>
-            <a:ext cx="914400" cy="1005840"/>
+            <a:off x="2834640" y="73152"/>
+            <a:ext cx="8961120" cy="914400"/>
           </a:xfrm>
           <a:prstGeom prst="rect">
             <a:avLst/>
@@ -4344,27 +4810,27 @@
           <a:p>
             <a:pPr algn="l"/>
             <a:r>
-              <a:rPr sz="4200" b="1" i="0">
+              <a:rPr sz="3800" b="1" i="0">
                 <a:solidFill>
                   <a:srgbClr val="FFFFFF"/>
                 </a:solidFill>
                 <a:latin typeface="Calibri"/>
               </a:rPr>
-              <a:t>03</a:t>
-            </a:r>
-          </a:p>
-        </p:txBody>
-      </p:sp>
-      <p:sp>
-        <p:nvSpPr>
-          <p:cNvPr id="5" name="TextBox 4"/>
+              <a:t>COMMENT UTILISER CE KIT ?</a:t>
+            </a:r>
+          </a:p>
+        </p:txBody>
+      </p:sp>
+      <p:sp>
+        <p:nvSpPr>
+          <p:cNvPr id="7" name="TextBox 6"/>
           <p:cNvSpPr txBox="1"/>
           <p:nvPr/>
         </p:nvSpPr>
         <p:spPr>
           <a:xfrm>
-            <a:off x="1280160" y="228600"/>
-            <a:ext cx="10058400" cy="822960"/>
+            <a:off x="2834640" y="914400"/>
+            <a:ext cx="8961120" cy="457200"/>
           </a:xfrm>
           <a:prstGeom prst="rect">
             <a:avLst/>
@@ -4379,27 +4845,27 @@
           <a:p>
             <a:pPr algn="l"/>
             <a:r>
-              <a:rPr sz="2600" b="1" i="0">
-                <a:solidFill>
-                  <a:srgbClr val="FFFFFF"/>
+              <a:rPr sz="1400" b="0" i="0">
+                <a:solidFill>
+                  <a:srgbClr val="CCE5E5"/>
                 </a:solidFill>
                 <a:latin typeface="Calibri"/>
               </a:rPr>
-              <a:t>Comment utiliser ce kit ?</a:t>
-            </a:r>
-          </a:p>
-        </p:txBody>
-      </p:sp>
-      <p:sp>
-        <p:nvSpPr>
-          <p:cNvPr id="6" name="TextBox 5"/>
+              <a:t>Guide pratique à l'intention des formateurs SHY-Performance</a:t>
+            </a:r>
+          </a:p>
+        </p:txBody>
+      </p:sp>
+      <p:sp>
+        <p:nvSpPr>
+          <p:cNvPr id="8" name="TextBox 7"/>
           <p:cNvSpPr txBox="1"/>
           <p:nvPr/>
         </p:nvSpPr>
         <p:spPr>
           <a:xfrm>
-            <a:off x="457200" y="1463040"/>
-            <a:ext cx="11247120" cy="5486400"/>
+            <a:off x="365760" y="1600200"/>
+            <a:ext cx="11430000" cy="4663440"/>
           </a:xfrm>
           <a:prstGeom prst="rect">
             <a:avLst/>
@@ -4414,111 +4880,197 @@
           <a:p>
             <a:pPr>
               <a:spcBef>
-                <a:spcPts val="400"/>
+                <a:spcPts val="600"/>
               </a:spcBef>
             </a:pPr>
             <a:r>
-              <a:rPr sz="1500">
+              <a:rPr sz="2200">
                 <a:solidFill>
                   <a:srgbClr val="1A1A1A"/>
                 </a:solidFill>
                 <a:latin typeface="Calibri"/>
               </a:rPr>
-              <a:t>▸ Chaque book jour est autonome — il peut être utilisé seul pour un rappel ciblé</a:t>
+              <a:t>▸  Chaque book jour est autonome — utilisable seul pour un rappel ou une remise à niveau ciblée</a:t>
             </a:r>
           </a:p>
           <a:p>
             <a:pPr>
               <a:spcBef>
-                <a:spcPts val="400"/>
+                <a:spcPts val="600"/>
               </a:spcBef>
             </a:pPr>
             <a:r>
-              <a:rPr sz="1500">
+              <a:rPr sz="2200">
                 <a:solidFill>
                   <a:srgbClr val="1A1A1A"/>
                 </a:solidFill>
                 <a:latin typeface="Calibri"/>
               </a:rPr>
-              <a:t>▸ Le Book 1 Synopsis sert de document de référence permanent</a:t>
+              <a:t>▸  Le Book 1 Synopsis sert de document de référence permanent tout au long de la formation</a:t>
             </a:r>
           </a:p>
           <a:p>
             <a:pPr>
               <a:spcBef>
-                <a:spcPts val="400"/>
+                <a:spcPts val="600"/>
               </a:spcBef>
             </a:pPr>
             <a:r>
-              <a:rPr sz="1500">
+              <a:rPr sz="2200">
                 <a:solidFill>
                   <a:srgbClr val="1A1A1A"/>
                 </a:solidFill>
                 <a:latin typeface="Calibri"/>
               </a:rPr>
-              <a:t>▸ Les slides de quiz (Book J5) sont prêtes à l'emploi pour tout nouvel apprenant</a:t>
+              <a:t>▸  Les slides de quiz (Book J5) sont prêtes à l'emploi pour tout nouvel apprenant</a:t>
             </a:r>
           </a:p>
           <a:p>
             <a:pPr>
               <a:spcBef>
-                <a:spcPts val="400"/>
+                <a:spcPts val="600"/>
               </a:spcBef>
             </a:pPr>
             <a:r>
-              <a:rPr sz="1500">
+              <a:rPr sz="2200">
                 <a:solidFill>
                   <a:srgbClr val="1A1A1A"/>
                 </a:solidFill>
                 <a:latin typeface="Calibri"/>
               </a:rPr>
-              <a:t>▸ Les jeux de rôle sont signalés par le picto 🎭 — prévoir binômes à l'avance</a:t>
+              <a:t>▸  Les jeux de rôle sont signalés par le picto 🎭 — prévoir les binômes à l'avance</a:t>
             </a:r>
           </a:p>
           <a:p>
             <a:pPr>
               <a:spcBef>
-                <a:spcPts val="400"/>
+                <a:spcPts val="600"/>
               </a:spcBef>
             </a:pPr>
             <a:r>
-              <a:rPr sz="1500">
+              <a:rPr sz="2200">
                 <a:solidFill>
                   <a:srgbClr val="1A1A1A"/>
                 </a:solidFill>
                 <a:latin typeface="Calibri"/>
               </a:rPr>
-              <a:t>▸ Les slides 'MANTRA' sont à laisser affichées pendant les exercices</a:t>
+              <a:t>▸  Les slides MANTRA sont à laisser affichées pendant les exercices pratiques</a:t>
             </a:r>
           </a:p>
           <a:p>
             <a:pPr>
               <a:spcBef>
-                <a:spcPts val="400"/>
+                <a:spcPts val="600"/>
               </a:spcBef>
             </a:pPr>
             <a:r>
-              <a:rPr sz="1500">
+              <a:rPr sz="2200">
                 <a:solidFill>
                   <a:srgbClr val="1A1A1A"/>
                 </a:solidFill>
                 <a:latin typeface="Calibri"/>
               </a:rPr>
-              <a:t>▸ La grille d'observation formateur est à imprimer avant chaque journée J3–J5</a:t>
-            </a:r>
-          </a:p>
-        </p:txBody>
-      </p:sp>
-      <p:sp>
-        <p:nvSpPr>
-          <p:cNvPr id="7" name="TextBox 6"/>
+              <a:t>▸  La grille d'observation formateur est à imprimer avant chaque journée J3, J4 et J5</a:t>
+            </a:r>
+          </a:p>
+        </p:txBody>
+      </p:sp>
+      <p:sp>
+        <p:nvSpPr>
+          <p:cNvPr id="9" name="Rectangle 8"/>
+          <p:cNvSpPr/>
+          <p:nvPr/>
+        </p:nvSpPr>
+        <p:spPr>
+          <a:xfrm>
+            <a:off x="0" y="6309360"/>
+            <a:ext cx="12188952" cy="548640"/>
+          </a:xfrm>
+          <a:prstGeom prst="rect">
+            <a:avLst/>
+          </a:prstGeom>
+          <a:solidFill>
+            <a:srgbClr val="004D4D"/>
+          </a:solidFill>
+          <a:ln>
+            <a:noFill/>
+          </a:ln>
+        </p:spPr>
+        <p:style>
+          <a:lnRef idx="1">
+            <a:schemeClr val="accent1"/>
+          </a:lnRef>
+          <a:fillRef idx="3">
+            <a:schemeClr val="accent1"/>
+          </a:fillRef>
+          <a:effectRef idx="2">
+            <a:schemeClr val="accent1"/>
+          </a:effectRef>
+          <a:fontRef idx="minor">
+            <a:schemeClr val="lt1"/>
+          </a:fontRef>
+        </p:style>
+        <p:txBody>
+          <a:bodyPr rtlCol="0" anchor="ctr"/>
+          <a:lstStyle/>
+          <a:p>
+            <a:pPr algn="ctr"/>
+          </a:p>
+        </p:txBody>
+      </p:sp>
+      <p:sp>
+        <p:nvSpPr>
+          <p:cNvPr id="10" name="Rectangle 9"/>
+          <p:cNvSpPr/>
+          <p:nvPr/>
+        </p:nvSpPr>
+        <p:spPr>
+          <a:xfrm>
+            <a:off x="0" y="6309360"/>
+            <a:ext cx="12188952" cy="36576"/>
+          </a:xfrm>
+          <a:prstGeom prst="rect">
+            <a:avLst/>
+          </a:prstGeom>
+          <a:solidFill>
+            <a:srgbClr val="FF0000"/>
+          </a:solidFill>
+          <a:ln>
+            <a:noFill/>
+          </a:ln>
+        </p:spPr>
+        <p:style>
+          <a:lnRef idx="1">
+            <a:schemeClr val="accent1"/>
+          </a:lnRef>
+          <a:fillRef idx="3">
+            <a:schemeClr val="accent1"/>
+          </a:fillRef>
+          <a:effectRef idx="2">
+            <a:schemeClr val="accent1"/>
+          </a:effectRef>
+          <a:fontRef idx="minor">
+            <a:schemeClr val="lt1"/>
+          </a:fontRef>
+        </p:style>
+        <p:txBody>
+          <a:bodyPr rtlCol="0" anchor="ctr"/>
+          <a:lstStyle/>
+          <a:p>
+            <a:pPr algn="ctr"/>
+          </a:p>
+        </p:txBody>
+      </p:sp>
+      <p:sp>
+        <p:nvSpPr>
+          <p:cNvPr id="11" name="TextBox 10"/>
           <p:cNvSpPr txBox="1"/>
           <p:nvPr/>
         </p:nvSpPr>
         <p:spPr>
           <a:xfrm>
-            <a:off x="274320" y="6519672"/>
-            <a:ext cx="9144000" cy="320040"/>
+            <a:off x="182880" y="6327648"/>
+            <a:ext cx="11823192" cy="512064"/>
           </a:xfrm>
           <a:prstGeom prst="rect">
             <a:avLst/>
@@ -4531,15 +5083,15 @@
           </a:bodyPr>
           <a:lstStyle/>
           <a:p>
-            <a:pPr algn="l"/>
-            <a:r>
-              <a:rPr sz="1000" b="0" i="0">
-                <a:solidFill>
-                  <a:srgbClr val="FFFFFF"/>
+            <a:pPr algn="ctr"/>
+            <a:r>
+              <a:rPr sz="800" b="0" i="0">
+                <a:solidFill>
+                  <a:srgbClr val="CCE5E5"/>
                 </a:solidFill>
                 <a:latin typeface="Calibri"/>
               </a:rPr>
-              <a:t>SHY-Performance  ×  FIDELIS  ×  UNICEF France</a:t>
+              <a:t>⚠  DOCUMENT PROTÉGÉ — Toute modification, rectification ou ajout est STRICTEMENT INTERDIT. Seules la Direction Générale de SHY-Performance ou une personne expressément mandatée sont autorisées à modifier ce document.  Élaboré par Tamou Eljerrari — Ingénieur en Formation — Sur ordre de la Directrice Générale Mme Salima Negrao.</a:t>
             </a:r>
           </a:p>
         </p:txBody>
@@ -4571,7 +5123,50 @@
         <p:spPr>
           <a:xfrm>
             <a:off x="0" y="0"/>
-            <a:ext cx="12188952" cy="1280160"/>
+            <a:ext cx="12188952" cy="6858000"/>
+          </a:xfrm>
+          <a:prstGeom prst="rect">
+            <a:avLst/>
+          </a:prstGeom>
+          <a:solidFill>
+            <a:srgbClr val="F0F7F7"/>
+          </a:solidFill>
+          <a:ln>
+            <a:noFill/>
+          </a:ln>
+        </p:spPr>
+        <p:style>
+          <a:lnRef idx="1">
+            <a:schemeClr val="accent1"/>
+          </a:lnRef>
+          <a:fillRef idx="3">
+            <a:schemeClr val="accent1"/>
+          </a:fillRef>
+          <a:effectRef idx="2">
+            <a:schemeClr val="accent1"/>
+          </a:effectRef>
+          <a:fontRef idx="minor">
+            <a:schemeClr val="lt1"/>
+          </a:fontRef>
+        </p:style>
+        <p:txBody>
+          <a:bodyPr rtlCol="0" anchor="ctr"/>
+          <a:lstStyle/>
+          <a:p>
+            <a:pPr algn="ctr"/>
+          </a:p>
+        </p:txBody>
+      </p:sp>
+      <p:sp>
+        <p:nvSpPr>
+          <p:cNvPr id="3" name="Rectangle 2"/>
+          <p:cNvSpPr/>
+          <p:nvPr/>
+        </p:nvSpPr>
+        <p:spPr>
+          <a:xfrm>
+            <a:off x="0" y="0"/>
+            <a:ext cx="12188952" cy="1463040"/>
           </a:xfrm>
           <a:prstGeom prst="rect">
             <a:avLst/>
@@ -4605,22 +5200,46 @@
           </a:p>
         </p:txBody>
       </p:sp>
-      <p:sp>
-        <p:nvSpPr>
-          <p:cNvPr id="3" name="Rectangle 2"/>
+      <p:pic>
+        <p:nvPicPr>
+          <p:cNvPr id="4" name="Picture 3" descr="shy_logo.png"/>
+          <p:cNvPicPr>
+            <a:picLocks noChangeAspect="1"/>
+          </p:cNvPicPr>
+          <p:nvPr/>
+        </p:nvPicPr>
+        <p:blipFill>
+          <a:blip r:embed="rId2"/>
+          <a:stretch>
+            <a:fillRect/>
+          </a:stretch>
+        </p:blipFill>
+        <p:spPr>
+          <a:xfrm>
+            <a:off x="228600" y="182880"/>
+            <a:ext cx="2275114" cy="1005840"/>
+          </a:xfrm>
+          <a:prstGeom prst="rect">
+            <a:avLst/>
+          </a:prstGeom>
+        </p:spPr>
+      </p:pic>
+      <p:sp>
+        <p:nvSpPr>
+          <p:cNvPr id="5" name="Rectangle 4"/>
           <p:cNvSpPr/>
           <p:nvPr/>
         </p:nvSpPr>
         <p:spPr>
           <a:xfrm>
-            <a:off x="0" y="6492240"/>
-            <a:ext cx="12188952" cy="365760"/>
+            <a:off x="2651760" y="182880"/>
+            <a:ext cx="36576" cy="1097280"/>
           </a:xfrm>
           <a:prstGeom prst="rect">
             <a:avLst/>
           </a:prstGeom>
           <a:solidFill>
-            <a:srgbClr val="008080"/>
+            <a:srgbClr val="FFFFFF"/>
           </a:solidFill>
           <a:ln>
             <a:noFill/>
@@ -4650,14 +5269,14 @@
       </p:sp>
       <p:sp>
         <p:nvSpPr>
-          <p:cNvPr id="4" name="TextBox 3"/>
+          <p:cNvPr id="6" name="TextBox 5"/>
           <p:cNvSpPr txBox="1"/>
           <p:nvPr/>
         </p:nvSpPr>
         <p:spPr>
           <a:xfrm>
-            <a:off x="274320" y="137160"/>
-            <a:ext cx="914400" cy="1005840"/>
+            <a:off x="2834640" y="73152"/>
+            <a:ext cx="8961120" cy="914400"/>
           </a:xfrm>
           <a:prstGeom prst="rect">
             <a:avLst/>
@@ -4672,27 +5291,27 @@
           <a:p>
             <a:pPr algn="l"/>
             <a:r>
-              <a:rPr sz="4200" b="1" i="0">
+              <a:rPr sz="3800" b="1" i="0">
                 <a:solidFill>
                   <a:srgbClr val="FFFFFF"/>
                 </a:solidFill>
                 <a:latin typeface="Calibri"/>
               </a:rPr>
-              <a:t>04</a:t>
-            </a:r>
-          </a:p>
-        </p:txBody>
-      </p:sp>
-      <p:sp>
-        <p:nvSpPr>
-          <p:cNvPr id="5" name="TextBox 4"/>
+              <a:t>CODE COULEUR &amp; LÉGENDE</a:t>
+            </a:r>
+          </a:p>
+        </p:txBody>
+      </p:sp>
+      <p:sp>
+        <p:nvSpPr>
+          <p:cNvPr id="7" name="TextBox 6"/>
           <p:cNvSpPr txBox="1"/>
           <p:nvPr/>
         </p:nvSpPr>
         <p:spPr>
           <a:xfrm>
-            <a:off x="1280160" y="228600"/>
-            <a:ext cx="10058400" cy="822960"/>
+            <a:off x="2834640" y="914400"/>
+            <a:ext cx="8961120" cy="457200"/>
           </a:xfrm>
           <a:prstGeom prst="rect">
             <a:avLst/>
@@ -4707,27 +5326,27 @@
           <a:p>
             <a:pPr algn="l"/>
             <a:r>
-              <a:rPr sz="2600" b="1" i="0">
-                <a:solidFill>
-                  <a:srgbClr val="FFFFFF"/>
+              <a:rPr sz="1400" b="0" i="0">
+                <a:solidFill>
+                  <a:srgbClr val="CCE5E5"/>
                 </a:solidFill>
                 <a:latin typeface="Calibri"/>
               </a:rPr>
-              <a:t>Code Couleur &amp; Légende</a:t>
-            </a:r>
-          </a:p>
-        </p:txBody>
-      </p:sp>
-      <p:sp>
-        <p:nvSpPr>
-          <p:cNvPr id="6" name="TextBox 5"/>
+              <a:t>Repères visuels pour une utilisation optimale du kit</a:t>
+            </a:r>
+          </a:p>
+        </p:txBody>
+      </p:sp>
+      <p:sp>
+        <p:nvSpPr>
+          <p:cNvPr id="8" name="TextBox 7"/>
           <p:cNvSpPr txBox="1"/>
           <p:nvPr/>
         </p:nvSpPr>
         <p:spPr>
           <a:xfrm>
-            <a:off x="457200" y="1463040"/>
-            <a:ext cx="11247120" cy="5486400"/>
+            <a:off x="365760" y="1600200"/>
+            <a:ext cx="11430000" cy="4663440"/>
           </a:xfrm>
           <a:prstGeom prst="rect">
             <a:avLst/>
@@ -4742,127 +5361,213 @@
           <a:p>
             <a:pPr>
               <a:spcBef>
-                <a:spcPts val="400"/>
+                <a:spcPts val="600"/>
               </a:spcBef>
             </a:pPr>
             <a:r>
-              <a:rPr sz="1500">
+              <a:rPr sz="2200">
                 <a:solidFill>
                   <a:srgbClr val="1A1A1A"/>
                 </a:solidFill>
                 <a:latin typeface="Calibri"/>
               </a:rPr>
-              <a:t>▸ 🟦 Bandeau TEAL #008080 — slide de contenu standard</a:t>
+              <a:t>▸  🟦  Bandeau TEAL #008080 — slide de contenu standard</a:t>
             </a:r>
           </a:p>
           <a:p>
             <a:pPr>
               <a:spcBef>
-                <a:spcPts val="400"/>
+                <a:spcPts val="600"/>
               </a:spcBef>
             </a:pPr>
             <a:r>
-              <a:rPr sz="1500">
+              <a:rPr sz="2200">
                 <a:solidFill>
                   <a:srgbClr val="1A1A1A"/>
                 </a:solidFill>
                 <a:latin typeface="Calibri"/>
               </a:rPr>
-              <a:t>▸ 🟥 Encart ROUGE — point d'attention critique, règle obligatoire</a:t>
+              <a:t>▸  🟡  Texte JAUNE #D4A017 — nom et identité SHY-Performance</a:t>
             </a:r>
           </a:p>
           <a:p>
             <a:pPr>
               <a:spcBef>
-                <a:spcPts val="400"/>
+                <a:spcPts val="600"/>
               </a:spcBef>
             </a:pPr>
             <a:r>
-              <a:rPr sz="1500">
+              <a:rPr sz="2200">
                 <a:solidFill>
                   <a:srgbClr val="1A1A1A"/>
                 </a:solidFill>
                 <a:latin typeface="Calibri"/>
               </a:rPr>
-              <a:t>▸ ⬜ Fond blanc / teal clair — exercice pratique ou définition</a:t>
+              <a:t>▸  🟥  Encart ROUGE — point d'attention critique ou règle obligatoire</a:t>
             </a:r>
           </a:p>
           <a:p>
             <a:pPr>
               <a:spcBef>
-                <a:spcPts val="400"/>
+                <a:spcPts val="600"/>
               </a:spcBef>
             </a:pPr>
             <a:r>
-              <a:rPr sz="1500">
+              <a:rPr sz="2200">
                 <a:solidFill>
                   <a:srgbClr val="1A1A1A"/>
                 </a:solidFill>
                 <a:latin typeface="Calibri"/>
               </a:rPr>
-              <a:t>▸ ★ Slide MANTRA — citation à mémoriser, laisser affichée</a:t>
+              <a:t>▸  ★   Slide MANTRA — citation à mémoriser, laisser affichée pendant l'exercice</a:t>
             </a:r>
           </a:p>
           <a:p>
             <a:pPr>
               <a:spcBef>
-                <a:spcPts val="400"/>
+                <a:spcPts val="600"/>
               </a:spcBef>
             </a:pPr>
             <a:r>
-              <a:rPr sz="1500">
+              <a:rPr sz="2200">
                 <a:solidFill>
                   <a:srgbClr val="1A1A1A"/>
                 </a:solidFill>
                 <a:latin typeface="Calibri"/>
               </a:rPr>
-              <a:t>▸ 🎭 Jeu de rôle — exercice en binôme ou groupe</a:t>
+              <a:t>▸  🎭  Jeu de rôle — exercice en binôme ou groupe, chronométré</a:t>
             </a:r>
           </a:p>
           <a:p>
             <a:pPr>
               <a:spcBef>
-                <a:spcPts val="400"/>
+                <a:spcPts val="600"/>
               </a:spcBef>
             </a:pPr>
             <a:r>
-              <a:rPr sz="1500">
+              <a:rPr sz="2200">
                 <a:solidFill>
                   <a:srgbClr val="1A1A1A"/>
                 </a:solidFill>
                 <a:latin typeface="Calibri"/>
               </a:rPr>
-              <a:t>▸ 📊 Grille d'évaluation — outil formateur</a:t>
+              <a:t>▸  📊  Grille d'évaluation — outil formateur, à imprimer avant la session</a:t>
             </a:r>
           </a:p>
           <a:p>
             <a:pPr>
               <a:spcBef>
-                <a:spcPts val="400"/>
+                <a:spcPts val="600"/>
               </a:spcBef>
             </a:pPr>
             <a:r>
-              <a:rPr sz="1500">
+              <a:rPr sz="2200">
                 <a:solidFill>
                   <a:srgbClr val="1A1A1A"/>
                 </a:solidFill>
                 <a:latin typeface="Calibri"/>
               </a:rPr>
-              <a:t>▸ ❓ Quiz — évaluation des connaissances</a:t>
-            </a:r>
-          </a:p>
-        </p:txBody>
-      </p:sp>
-      <p:sp>
-        <p:nvSpPr>
-          <p:cNvPr id="7" name="TextBox 6"/>
+              <a:t>▸  ❓  Quiz — évaluation des connaissances, prêt à l'emploi pour nouveaux apprenants</a:t>
+            </a:r>
+          </a:p>
+        </p:txBody>
+      </p:sp>
+      <p:sp>
+        <p:nvSpPr>
+          <p:cNvPr id="9" name="Rectangle 8"/>
+          <p:cNvSpPr/>
+          <p:nvPr/>
+        </p:nvSpPr>
+        <p:spPr>
+          <a:xfrm>
+            <a:off x="0" y="6309360"/>
+            <a:ext cx="12188952" cy="548640"/>
+          </a:xfrm>
+          <a:prstGeom prst="rect">
+            <a:avLst/>
+          </a:prstGeom>
+          <a:solidFill>
+            <a:srgbClr val="004D4D"/>
+          </a:solidFill>
+          <a:ln>
+            <a:noFill/>
+          </a:ln>
+        </p:spPr>
+        <p:style>
+          <a:lnRef idx="1">
+            <a:schemeClr val="accent1"/>
+          </a:lnRef>
+          <a:fillRef idx="3">
+            <a:schemeClr val="accent1"/>
+          </a:fillRef>
+          <a:effectRef idx="2">
+            <a:schemeClr val="accent1"/>
+          </a:effectRef>
+          <a:fontRef idx="minor">
+            <a:schemeClr val="lt1"/>
+          </a:fontRef>
+        </p:style>
+        <p:txBody>
+          <a:bodyPr rtlCol="0" anchor="ctr"/>
+          <a:lstStyle/>
+          <a:p>
+            <a:pPr algn="ctr"/>
+          </a:p>
+        </p:txBody>
+      </p:sp>
+      <p:sp>
+        <p:nvSpPr>
+          <p:cNvPr id="10" name="Rectangle 9"/>
+          <p:cNvSpPr/>
+          <p:nvPr/>
+        </p:nvSpPr>
+        <p:spPr>
+          <a:xfrm>
+            <a:off x="0" y="6309360"/>
+            <a:ext cx="12188952" cy="36576"/>
+          </a:xfrm>
+          <a:prstGeom prst="rect">
+            <a:avLst/>
+          </a:prstGeom>
+          <a:solidFill>
+            <a:srgbClr val="FF0000"/>
+          </a:solidFill>
+          <a:ln>
+            <a:noFill/>
+          </a:ln>
+        </p:spPr>
+        <p:style>
+          <a:lnRef idx="1">
+            <a:schemeClr val="accent1"/>
+          </a:lnRef>
+          <a:fillRef idx="3">
+            <a:schemeClr val="accent1"/>
+          </a:fillRef>
+          <a:effectRef idx="2">
+            <a:schemeClr val="accent1"/>
+          </a:effectRef>
+          <a:fontRef idx="minor">
+            <a:schemeClr val="lt1"/>
+          </a:fontRef>
+        </p:style>
+        <p:txBody>
+          <a:bodyPr rtlCol="0" anchor="ctr"/>
+          <a:lstStyle/>
+          <a:p>
+            <a:pPr algn="ctr"/>
+          </a:p>
+        </p:txBody>
+      </p:sp>
+      <p:sp>
+        <p:nvSpPr>
+          <p:cNvPr id="11" name="TextBox 10"/>
           <p:cNvSpPr txBox="1"/>
           <p:nvPr/>
         </p:nvSpPr>
         <p:spPr>
           <a:xfrm>
-            <a:off x="274320" y="6519672"/>
-            <a:ext cx="9144000" cy="320040"/>
+            <a:off x="182880" y="6327648"/>
+            <a:ext cx="11823192" cy="512064"/>
           </a:xfrm>
           <a:prstGeom prst="rect">
             <a:avLst/>
@@ -4875,15 +5580,15 @@
           </a:bodyPr>
           <a:lstStyle/>
           <a:p>
-            <a:pPr algn="l"/>
-            <a:r>
-              <a:rPr sz="1000" b="0" i="0">
-                <a:solidFill>
-                  <a:srgbClr val="FFFFFF"/>
+            <a:pPr algn="ctr"/>
+            <a:r>
+              <a:rPr sz="800" b="0" i="0">
+                <a:solidFill>
+                  <a:srgbClr val="CCE5E5"/>
                 </a:solidFill>
                 <a:latin typeface="Calibri"/>
               </a:rPr>
-              <a:t>SHY-Performance  ×  FIDELIS  ×  UNICEF France</a:t>
+              <a:t>⚠  DOCUMENT PROTÉGÉ — Toute modification, rectification ou ajout est STRICTEMENT INTERDIT. Seules la Direction Générale de SHY-Performance ou une personne expressément mandatée sont autorisées à modifier ce document.  Élaboré par Tamou Eljerrari — Ingénieur en Formation — Sur ordre de la Directrice Générale Mme Salima Negrao.</a:t>
             </a:r>
           </a:p>
         </p:txBody>
@@ -4915,7 +5620,50 @@
         <p:spPr>
           <a:xfrm>
             <a:off x="0" y="0"/>
-            <a:ext cx="12188952" cy="1280160"/>
+            <a:ext cx="12188952" cy="6858000"/>
+          </a:xfrm>
+          <a:prstGeom prst="rect">
+            <a:avLst/>
+          </a:prstGeom>
+          <a:solidFill>
+            <a:srgbClr val="F0F7F7"/>
+          </a:solidFill>
+          <a:ln>
+            <a:noFill/>
+          </a:ln>
+        </p:spPr>
+        <p:style>
+          <a:lnRef idx="1">
+            <a:schemeClr val="accent1"/>
+          </a:lnRef>
+          <a:fillRef idx="3">
+            <a:schemeClr val="accent1"/>
+          </a:fillRef>
+          <a:effectRef idx="2">
+            <a:schemeClr val="accent1"/>
+          </a:effectRef>
+          <a:fontRef idx="minor">
+            <a:schemeClr val="lt1"/>
+          </a:fontRef>
+        </p:style>
+        <p:txBody>
+          <a:bodyPr rtlCol="0" anchor="ctr"/>
+          <a:lstStyle/>
+          <a:p>
+            <a:pPr algn="ctr"/>
+          </a:p>
+        </p:txBody>
+      </p:sp>
+      <p:sp>
+        <p:nvSpPr>
+          <p:cNvPr id="3" name="Rectangle 2"/>
+          <p:cNvSpPr/>
+          <p:nvPr/>
+        </p:nvSpPr>
+        <p:spPr>
+          <a:xfrm>
+            <a:off x="0" y="0"/>
+            <a:ext cx="12188952" cy="1463040"/>
           </a:xfrm>
           <a:prstGeom prst="rect">
             <a:avLst/>
@@ -4949,16 +5697,196 @@
           </a:p>
         </p:txBody>
       </p:sp>
-      <p:sp>
-        <p:nvSpPr>
-          <p:cNvPr id="3" name="Rectangle 2"/>
+      <p:pic>
+        <p:nvPicPr>
+          <p:cNvPr id="4" name="Picture 3" descr="shy_logo.png"/>
+          <p:cNvPicPr>
+            <a:picLocks noChangeAspect="1"/>
+          </p:cNvPicPr>
+          <p:nvPr/>
+        </p:nvPicPr>
+        <p:blipFill>
+          <a:blip r:embed="rId2"/>
+          <a:stretch>
+            <a:fillRect/>
+          </a:stretch>
+        </p:blipFill>
+        <p:spPr>
+          <a:xfrm>
+            <a:off x="228600" y="182880"/>
+            <a:ext cx="2275114" cy="1005840"/>
+          </a:xfrm>
+          <a:prstGeom prst="rect">
+            <a:avLst/>
+          </a:prstGeom>
+        </p:spPr>
+      </p:pic>
+      <p:sp>
+        <p:nvSpPr>
+          <p:cNvPr id="5" name="Rectangle 4"/>
           <p:cNvSpPr/>
           <p:nvPr/>
         </p:nvSpPr>
         <p:spPr>
           <a:xfrm>
-            <a:off x="0" y="6492240"/>
-            <a:ext cx="12188952" cy="365760"/>
+            <a:off x="2651760" y="182880"/>
+            <a:ext cx="36576" cy="1097280"/>
+          </a:xfrm>
+          <a:prstGeom prst="rect">
+            <a:avLst/>
+          </a:prstGeom>
+          <a:solidFill>
+            <a:srgbClr val="FFFFFF"/>
+          </a:solidFill>
+          <a:ln>
+            <a:noFill/>
+          </a:ln>
+        </p:spPr>
+        <p:style>
+          <a:lnRef idx="1">
+            <a:schemeClr val="accent1"/>
+          </a:lnRef>
+          <a:fillRef idx="3">
+            <a:schemeClr val="accent1"/>
+          </a:fillRef>
+          <a:effectRef idx="2">
+            <a:schemeClr val="accent1"/>
+          </a:effectRef>
+          <a:fontRef idx="minor">
+            <a:schemeClr val="lt1"/>
+          </a:fontRef>
+        </p:style>
+        <p:txBody>
+          <a:bodyPr rtlCol="0" anchor="ctr"/>
+          <a:lstStyle/>
+          <a:p>
+            <a:pPr algn="ctr"/>
+          </a:p>
+        </p:txBody>
+      </p:sp>
+      <p:sp>
+        <p:nvSpPr>
+          <p:cNvPr id="6" name="TextBox 5"/>
+          <p:cNvSpPr txBox="1"/>
+          <p:nvPr/>
+        </p:nvSpPr>
+        <p:spPr>
+          <a:xfrm>
+            <a:off x="2834640" y="73152"/>
+            <a:ext cx="8961120" cy="914400"/>
+          </a:xfrm>
+          <a:prstGeom prst="rect">
+            <a:avLst/>
+          </a:prstGeom>
+          <a:noFill/>
+        </p:spPr>
+        <p:txBody>
+          <a:bodyPr wrap="square">
+            <a:spAutoFit/>
+          </a:bodyPr>
+          <a:lstStyle/>
+          <a:p>
+            <a:pPr algn="l"/>
+            <a:r>
+              <a:rPr sz="3800" b="1" i="0">
+                <a:solidFill>
+                  <a:srgbClr val="FFFFFF"/>
+                </a:solidFill>
+                <a:latin typeface="Calibri"/>
+              </a:rPr>
+              <a:t>PLANNING RECOMMANDÉ — 5 JOURS</a:t>
+            </a:r>
+          </a:p>
+        </p:txBody>
+      </p:sp>
+      <p:sp>
+        <p:nvSpPr>
+          <p:cNvPr id="7" name="TextBox 6"/>
+          <p:cNvSpPr txBox="1"/>
+          <p:nvPr/>
+        </p:nvSpPr>
+        <p:spPr>
+          <a:xfrm>
+            <a:off x="2834640" y="914400"/>
+            <a:ext cx="8961120" cy="457200"/>
+          </a:xfrm>
+          <a:prstGeom prst="rect">
+            <a:avLst/>
+          </a:prstGeom>
+          <a:noFill/>
+        </p:spPr>
+        <p:txBody>
+          <a:bodyPr wrap="square">
+            <a:spAutoFit/>
+          </a:bodyPr>
+          <a:lstStyle/>
+          <a:p>
+            <a:pPr algn="l"/>
+            <a:r>
+              <a:rPr sz="1400" b="0" i="0">
+                <a:solidFill>
+                  <a:srgbClr val="CCE5E5"/>
+                </a:solidFill>
+                <a:latin typeface="Calibri"/>
+              </a:rPr>
+              <a:t>Organisation type d'une session FIM complète</a:t>
+            </a:r>
+          </a:p>
+        </p:txBody>
+      </p:sp>
+      <p:sp>
+        <p:nvSpPr>
+          <p:cNvPr id="8" name="Rectangle 7"/>
+          <p:cNvSpPr/>
+          <p:nvPr/>
+        </p:nvSpPr>
+        <p:spPr>
+          <a:xfrm>
+            <a:off x="320040" y="1600200"/>
+            <a:ext cx="2194560" cy="4389120"/>
+          </a:xfrm>
+          <a:prstGeom prst="rect">
+            <a:avLst/>
+          </a:prstGeom>
+          <a:solidFill>
+            <a:srgbClr val="FFFFFF"/>
+          </a:solidFill>
+          <a:ln>
+            <a:noFill/>
+          </a:ln>
+        </p:spPr>
+        <p:style>
+          <a:lnRef idx="1">
+            <a:schemeClr val="accent1"/>
+          </a:lnRef>
+          <a:fillRef idx="3">
+            <a:schemeClr val="accent1"/>
+          </a:fillRef>
+          <a:effectRef idx="2">
+            <a:schemeClr val="accent1"/>
+          </a:effectRef>
+          <a:fontRef idx="minor">
+            <a:schemeClr val="lt1"/>
+          </a:fontRef>
+        </p:style>
+        <p:txBody>
+          <a:bodyPr rtlCol="0" anchor="ctr"/>
+          <a:lstStyle/>
+          <a:p>
+            <a:pPr algn="ctr"/>
+          </a:p>
+        </p:txBody>
+      </p:sp>
+      <p:sp>
+        <p:nvSpPr>
+          <p:cNvPr id="9" name="Rectangle 8"/>
+          <p:cNvSpPr/>
+          <p:nvPr/>
+        </p:nvSpPr>
+        <p:spPr>
+          <a:xfrm>
+            <a:off x="320040" y="1600200"/>
+            <a:ext cx="2194560" cy="594360"/>
           </a:xfrm>
           <a:prstGeom prst="rect">
             <a:avLst/>
@@ -4994,14 +5922,14 @@
       </p:sp>
       <p:sp>
         <p:nvSpPr>
-          <p:cNvPr id="4" name="TextBox 3"/>
+          <p:cNvPr id="10" name="TextBox 9"/>
           <p:cNvSpPr txBox="1"/>
           <p:nvPr/>
         </p:nvSpPr>
         <p:spPr>
           <a:xfrm>
-            <a:off x="274320" y="137160"/>
-            <a:ext cx="914400" cy="1005840"/>
+            <a:off x="320040" y="1600200"/>
+            <a:ext cx="2194560" cy="594360"/>
           </a:xfrm>
           <a:prstGeom prst="rect">
             <a:avLst/>
@@ -5014,29 +5942,29 @@
           </a:bodyPr>
           <a:lstStyle/>
           <a:p>
-            <a:pPr algn="l"/>
-            <a:r>
-              <a:rPr sz="4200" b="1" i="0">
-                <a:solidFill>
-                  <a:srgbClr val="FFFFFF"/>
+            <a:pPr algn="ctr"/>
+            <a:r>
+              <a:rPr sz="2800" b="1" i="0">
+                <a:solidFill>
+                  <a:srgbClr val="D4A017"/>
                 </a:solidFill>
                 <a:latin typeface="Calibri"/>
               </a:rPr>
-              <a:t>05</a:t>
-            </a:r>
-          </a:p>
-        </p:txBody>
-      </p:sp>
-      <p:sp>
-        <p:nvSpPr>
-          <p:cNvPr id="5" name="TextBox 4"/>
+              <a:t>J1</a:t>
+            </a:r>
+          </a:p>
+        </p:txBody>
+      </p:sp>
+      <p:sp>
+        <p:nvSpPr>
+          <p:cNvPr id="11" name="TextBox 10"/>
           <p:cNvSpPr txBox="1"/>
           <p:nvPr/>
         </p:nvSpPr>
         <p:spPr>
           <a:xfrm>
-            <a:off x="1280160" y="228600"/>
-            <a:ext cx="10058400" cy="822960"/>
+            <a:off x="411480" y="2240280"/>
+            <a:ext cx="2011680" cy="731520"/>
           </a:xfrm>
           <a:prstGeom prst="rect">
             <a:avLst/>
@@ -5049,29 +5977,29 @@
           </a:bodyPr>
           <a:lstStyle/>
           <a:p>
-            <a:pPr algn="l"/>
-            <a:r>
-              <a:rPr sz="2600" b="1" i="0">
-                <a:solidFill>
-                  <a:srgbClr val="FFFFFF"/>
+            <a:pPr algn="ctr"/>
+            <a:r>
+              <a:rPr sz="1400" b="1" i="0">
+                <a:solidFill>
+                  <a:srgbClr val="008080"/>
                 </a:solidFill>
                 <a:latin typeface="Calibri"/>
               </a:rPr>
-              <a:t>Planning Recommandé sur 5 Jours</a:t>
-            </a:r>
-          </a:p>
-        </p:txBody>
-      </p:sp>
-      <p:sp>
-        <p:nvSpPr>
-          <p:cNvPr id="6" name="TextBox 5"/>
+              <a:t>Fondations &amp; Mission</a:t>
+            </a:r>
+          </a:p>
+        </p:txBody>
+      </p:sp>
+      <p:sp>
+        <p:nvSpPr>
+          <p:cNvPr id="12" name="TextBox 11"/>
           <p:cNvSpPr txBox="1"/>
           <p:nvPr/>
         </p:nvSpPr>
         <p:spPr>
           <a:xfrm>
-            <a:off x="457200" y="1463040"/>
-            <a:ext cx="11247120" cy="5486400"/>
+            <a:off x="411480" y="3063240"/>
+            <a:ext cx="2011680" cy="1097280"/>
           </a:xfrm>
           <a:prstGeom prst="rect">
             <a:avLst/>
@@ -5084,129 +6012,31 @@
           </a:bodyPr>
           <a:lstStyle/>
           <a:p>
-            <a:pPr>
-              <a:spcBef>
-                <a:spcPts val="400"/>
-              </a:spcBef>
-            </a:pPr>
-            <a:r>
-              <a:rPr sz="1500">
+            <a:pPr algn="ctr"/>
+            <a:r>
+              <a:rPr sz="1300" b="0" i="0">
                 <a:solidFill>
                   <a:srgbClr val="1A1A1A"/>
                 </a:solidFill>
                 <a:latin typeface="Calibri"/>
               </a:rPr>
-              <a:t>▸ JOUR 1 — Fondations &amp; Mission | 9h30–17h30 | 6h40 production</a:t>
-            </a:r>
-          </a:p>
-          <a:p>
-            <a:pPr>
-              <a:spcBef>
-                <a:spcPts val="400"/>
-              </a:spcBef>
-            </a:pPr>
-            <a:r>
-              <a:rPr sz="1500">
-                <a:solidFill>
-                  <a:srgbClr val="1A1A1A"/>
-                </a:solidFill>
-                <a:latin typeface="Calibri"/>
-              </a:rPr>
-              <a:t>▸ JOUR 2 — Monde Associatif &amp; Humanitaire | 9h30–17h30 | 6h40 production</a:t>
-            </a:r>
-          </a:p>
-          <a:p>
-            <a:pPr>
-              <a:spcBef>
-                <a:spcPts val="400"/>
-              </a:spcBef>
-            </a:pPr>
-            <a:r>
-              <a:rPr sz="1500">
-                <a:solidFill>
-                  <a:srgbClr val="1A1A1A"/>
-                </a:solidFill>
-                <a:latin typeface="Calibri"/>
-              </a:rPr>
-              <a:t>▸ JOUR 3 — Analyse et Lecture du Script | 9h30–17h30 | Exercices intensifs</a:t>
-            </a:r>
-          </a:p>
-          <a:p>
-            <a:pPr>
-              <a:spcBef>
-                <a:spcPts val="400"/>
-              </a:spcBef>
-            </a:pPr>
-            <a:r>
-              <a:rPr sz="1500">
-                <a:solidFill>
-                  <a:srgbClr val="1A1A1A"/>
-                </a:solidFill>
-                <a:latin typeface="Calibri"/>
-              </a:rPr>
-              <a:t>▸ JOUR 4 — Traitement des Objections | 9h30–17h30 | Jeux de rôle</a:t>
-            </a:r>
-          </a:p>
-          <a:p>
-            <a:pPr>
-              <a:spcBef>
-                <a:spcPts val="400"/>
-              </a:spcBef>
-            </a:pPr>
-            <a:r>
-              <a:rPr sz="1500">
-                <a:solidFill>
-                  <a:srgbClr val="1A1A1A"/>
-                </a:solidFill>
-                <a:latin typeface="Calibri"/>
-              </a:rPr>
-              <a:t>▸ JOUR 5 — Synthèse Générale &amp; Simulations | 9h30–17h30 | Quiz + Certifications</a:t>
-            </a:r>
-          </a:p>
-          <a:p>
-            <a:pPr>
-              <a:spcBef>
-                <a:spcPts val="400"/>
-              </a:spcBef>
-            </a:pPr>
-            <a:r>
-              <a:rPr sz="1500">
-                <a:solidFill>
-                  <a:srgbClr val="1A1A1A"/>
-                </a:solidFill>
-                <a:latin typeface="Calibri"/>
-              </a:rPr>
-              <a:t>▸ Pause déjeuner recommandée : 13h00–14h00</a:t>
-            </a:r>
-          </a:p>
-          <a:p>
-            <a:pPr>
-              <a:spcBef>
-                <a:spcPts val="400"/>
-              </a:spcBef>
-            </a:pPr>
-            <a:r>
-              <a:rPr sz="1500">
-                <a:solidFill>
-                  <a:srgbClr val="1A1A1A"/>
-                </a:solidFill>
-                <a:latin typeface="Calibri"/>
-              </a:rPr>
-              <a:t>▸ Pause matin : 11h00 | Pause après-midi : 15h30</a:t>
-            </a:r>
-          </a:p>
-        </p:txBody>
-      </p:sp>
-      <p:sp>
-        <p:nvSpPr>
-          <p:cNvPr id="7" name="TextBox 6"/>
+              <a:t>9h30 – 17h30
+6h40 production
+effective</a:t>
+            </a:r>
+          </a:p>
+        </p:txBody>
+      </p:sp>
+      <p:sp>
+        <p:nvSpPr>
+          <p:cNvPr id="13" name="TextBox 12"/>
           <p:cNvSpPr txBox="1"/>
           <p:nvPr/>
         </p:nvSpPr>
         <p:spPr>
           <a:xfrm>
-            <a:off x="274320" y="6519672"/>
-            <a:ext cx="9144000" cy="320040"/>
+            <a:off x="411480" y="4251960"/>
+            <a:ext cx="2011680" cy="1097280"/>
           </a:xfrm>
           <a:prstGeom prst="rect">
             <a:avLst/>
@@ -5219,15 +6049,1058 @@
           </a:bodyPr>
           <a:lstStyle/>
           <a:p>
-            <a:pPr algn="l"/>
-            <a:r>
-              <a:rPr sz="1000" b="0" i="0">
-                <a:solidFill>
-                  <a:srgbClr val="FFFFFF"/>
+            <a:pPr algn="ctr"/>
+            <a:r>
+              <a:rPr sz="1200" b="0" i="1">
+                <a:solidFill>
+                  <a:srgbClr val="555555"/>
                 </a:solidFill>
                 <a:latin typeface="Calibri"/>
               </a:rPr>
-              <a:t>SHY-Performance  ×  FIDELIS  ×  UNICEF France</a:t>
+              <a:t>Pause 11h00
+Déjeuner 13h
+Pause 15h30</a:t>
+            </a:r>
+          </a:p>
+        </p:txBody>
+      </p:sp>
+      <p:sp>
+        <p:nvSpPr>
+          <p:cNvPr id="14" name="Rectangle 13"/>
+          <p:cNvSpPr/>
+          <p:nvPr/>
+        </p:nvSpPr>
+        <p:spPr>
+          <a:xfrm>
+            <a:off x="2697480" y="1600200"/>
+            <a:ext cx="2194560" cy="4389120"/>
+          </a:xfrm>
+          <a:prstGeom prst="rect">
+            <a:avLst/>
+          </a:prstGeom>
+          <a:solidFill>
+            <a:srgbClr val="FFFFFF"/>
+          </a:solidFill>
+          <a:ln>
+            <a:noFill/>
+          </a:ln>
+        </p:spPr>
+        <p:style>
+          <a:lnRef idx="1">
+            <a:schemeClr val="accent1"/>
+          </a:lnRef>
+          <a:fillRef idx="3">
+            <a:schemeClr val="accent1"/>
+          </a:fillRef>
+          <a:effectRef idx="2">
+            <a:schemeClr val="accent1"/>
+          </a:effectRef>
+          <a:fontRef idx="minor">
+            <a:schemeClr val="lt1"/>
+          </a:fontRef>
+        </p:style>
+        <p:txBody>
+          <a:bodyPr rtlCol="0" anchor="ctr"/>
+          <a:lstStyle/>
+          <a:p>
+            <a:pPr algn="ctr"/>
+          </a:p>
+        </p:txBody>
+      </p:sp>
+      <p:sp>
+        <p:nvSpPr>
+          <p:cNvPr id="15" name="Rectangle 14"/>
+          <p:cNvSpPr/>
+          <p:nvPr/>
+        </p:nvSpPr>
+        <p:spPr>
+          <a:xfrm>
+            <a:off x="2697480" y="1600200"/>
+            <a:ext cx="2194560" cy="594360"/>
+          </a:xfrm>
+          <a:prstGeom prst="rect">
+            <a:avLst/>
+          </a:prstGeom>
+          <a:solidFill>
+            <a:srgbClr val="008080"/>
+          </a:solidFill>
+          <a:ln>
+            <a:noFill/>
+          </a:ln>
+        </p:spPr>
+        <p:style>
+          <a:lnRef idx="1">
+            <a:schemeClr val="accent1"/>
+          </a:lnRef>
+          <a:fillRef idx="3">
+            <a:schemeClr val="accent1"/>
+          </a:fillRef>
+          <a:effectRef idx="2">
+            <a:schemeClr val="accent1"/>
+          </a:effectRef>
+          <a:fontRef idx="minor">
+            <a:schemeClr val="lt1"/>
+          </a:fontRef>
+        </p:style>
+        <p:txBody>
+          <a:bodyPr rtlCol="0" anchor="ctr"/>
+          <a:lstStyle/>
+          <a:p>
+            <a:pPr algn="ctr"/>
+          </a:p>
+        </p:txBody>
+      </p:sp>
+      <p:sp>
+        <p:nvSpPr>
+          <p:cNvPr id="16" name="TextBox 15"/>
+          <p:cNvSpPr txBox="1"/>
+          <p:nvPr/>
+        </p:nvSpPr>
+        <p:spPr>
+          <a:xfrm>
+            <a:off x="2697480" y="1600200"/>
+            <a:ext cx="2194560" cy="594360"/>
+          </a:xfrm>
+          <a:prstGeom prst="rect">
+            <a:avLst/>
+          </a:prstGeom>
+          <a:noFill/>
+        </p:spPr>
+        <p:txBody>
+          <a:bodyPr wrap="square">
+            <a:spAutoFit/>
+          </a:bodyPr>
+          <a:lstStyle/>
+          <a:p>
+            <a:pPr algn="ctr"/>
+            <a:r>
+              <a:rPr sz="2800" b="1" i="0">
+                <a:solidFill>
+                  <a:srgbClr val="D4A017"/>
+                </a:solidFill>
+                <a:latin typeface="Calibri"/>
+              </a:rPr>
+              <a:t>J2</a:t>
+            </a:r>
+          </a:p>
+        </p:txBody>
+      </p:sp>
+      <p:sp>
+        <p:nvSpPr>
+          <p:cNvPr id="17" name="TextBox 16"/>
+          <p:cNvSpPr txBox="1"/>
+          <p:nvPr/>
+        </p:nvSpPr>
+        <p:spPr>
+          <a:xfrm>
+            <a:off x="2788920" y="2240280"/>
+            <a:ext cx="2011680" cy="731520"/>
+          </a:xfrm>
+          <a:prstGeom prst="rect">
+            <a:avLst/>
+          </a:prstGeom>
+          <a:noFill/>
+        </p:spPr>
+        <p:txBody>
+          <a:bodyPr wrap="square">
+            <a:spAutoFit/>
+          </a:bodyPr>
+          <a:lstStyle/>
+          <a:p>
+            <a:pPr algn="ctr"/>
+            <a:r>
+              <a:rPr sz="1400" b="1" i="0">
+                <a:solidFill>
+                  <a:srgbClr val="008080"/>
+                </a:solidFill>
+                <a:latin typeface="Calibri"/>
+              </a:rPr>
+              <a:t>Monde Associatif &amp; Humanitaire</a:t>
+            </a:r>
+          </a:p>
+        </p:txBody>
+      </p:sp>
+      <p:sp>
+        <p:nvSpPr>
+          <p:cNvPr id="18" name="TextBox 17"/>
+          <p:cNvSpPr txBox="1"/>
+          <p:nvPr/>
+        </p:nvSpPr>
+        <p:spPr>
+          <a:xfrm>
+            <a:off x="2788920" y="3063240"/>
+            <a:ext cx="2011680" cy="1097280"/>
+          </a:xfrm>
+          <a:prstGeom prst="rect">
+            <a:avLst/>
+          </a:prstGeom>
+          <a:noFill/>
+        </p:spPr>
+        <p:txBody>
+          <a:bodyPr wrap="square">
+            <a:spAutoFit/>
+          </a:bodyPr>
+          <a:lstStyle/>
+          <a:p>
+            <a:pPr algn="ctr"/>
+            <a:r>
+              <a:rPr sz="1300" b="0" i="0">
+                <a:solidFill>
+                  <a:srgbClr val="1A1A1A"/>
+                </a:solidFill>
+                <a:latin typeface="Calibri"/>
+              </a:rPr>
+              <a:t>9h30 – 17h30
+6h40 production
+effective</a:t>
+            </a:r>
+          </a:p>
+        </p:txBody>
+      </p:sp>
+      <p:sp>
+        <p:nvSpPr>
+          <p:cNvPr id="19" name="TextBox 18"/>
+          <p:cNvSpPr txBox="1"/>
+          <p:nvPr/>
+        </p:nvSpPr>
+        <p:spPr>
+          <a:xfrm>
+            <a:off x="2788920" y="4251960"/>
+            <a:ext cx="2011680" cy="1097280"/>
+          </a:xfrm>
+          <a:prstGeom prst="rect">
+            <a:avLst/>
+          </a:prstGeom>
+          <a:noFill/>
+        </p:spPr>
+        <p:txBody>
+          <a:bodyPr wrap="square">
+            <a:spAutoFit/>
+          </a:bodyPr>
+          <a:lstStyle/>
+          <a:p>
+            <a:pPr algn="ctr"/>
+            <a:r>
+              <a:rPr sz="1200" b="0" i="1">
+                <a:solidFill>
+                  <a:srgbClr val="555555"/>
+                </a:solidFill>
+                <a:latin typeface="Calibri"/>
+              </a:rPr>
+              <a:t>Pause 11h00
+Déjeuner 13h
+Pause 15h30</a:t>
+            </a:r>
+          </a:p>
+        </p:txBody>
+      </p:sp>
+      <p:sp>
+        <p:nvSpPr>
+          <p:cNvPr id="20" name="Rectangle 19"/>
+          <p:cNvSpPr/>
+          <p:nvPr/>
+        </p:nvSpPr>
+        <p:spPr>
+          <a:xfrm>
+            <a:off x="5074920" y="1600200"/>
+            <a:ext cx="2194560" cy="4389120"/>
+          </a:xfrm>
+          <a:prstGeom prst="rect">
+            <a:avLst/>
+          </a:prstGeom>
+          <a:solidFill>
+            <a:srgbClr val="FFFFFF"/>
+          </a:solidFill>
+          <a:ln>
+            <a:noFill/>
+          </a:ln>
+        </p:spPr>
+        <p:style>
+          <a:lnRef idx="1">
+            <a:schemeClr val="accent1"/>
+          </a:lnRef>
+          <a:fillRef idx="3">
+            <a:schemeClr val="accent1"/>
+          </a:fillRef>
+          <a:effectRef idx="2">
+            <a:schemeClr val="accent1"/>
+          </a:effectRef>
+          <a:fontRef idx="minor">
+            <a:schemeClr val="lt1"/>
+          </a:fontRef>
+        </p:style>
+        <p:txBody>
+          <a:bodyPr rtlCol="0" anchor="ctr"/>
+          <a:lstStyle/>
+          <a:p>
+            <a:pPr algn="ctr"/>
+          </a:p>
+        </p:txBody>
+      </p:sp>
+      <p:sp>
+        <p:nvSpPr>
+          <p:cNvPr id="21" name="Rectangle 20"/>
+          <p:cNvSpPr/>
+          <p:nvPr/>
+        </p:nvSpPr>
+        <p:spPr>
+          <a:xfrm>
+            <a:off x="5074920" y="1600200"/>
+            <a:ext cx="2194560" cy="594360"/>
+          </a:xfrm>
+          <a:prstGeom prst="rect">
+            <a:avLst/>
+          </a:prstGeom>
+          <a:solidFill>
+            <a:srgbClr val="008080"/>
+          </a:solidFill>
+          <a:ln>
+            <a:noFill/>
+          </a:ln>
+        </p:spPr>
+        <p:style>
+          <a:lnRef idx="1">
+            <a:schemeClr val="accent1"/>
+          </a:lnRef>
+          <a:fillRef idx="3">
+            <a:schemeClr val="accent1"/>
+          </a:fillRef>
+          <a:effectRef idx="2">
+            <a:schemeClr val="accent1"/>
+          </a:effectRef>
+          <a:fontRef idx="minor">
+            <a:schemeClr val="lt1"/>
+          </a:fontRef>
+        </p:style>
+        <p:txBody>
+          <a:bodyPr rtlCol="0" anchor="ctr"/>
+          <a:lstStyle/>
+          <a:p>
+            <a:pPr algn="ctr"/>
+          </a:p>
+        </p:txBody>
+      </p:sp>
+      <p:sp>
+        <p:nvSpPr>
+          <p:cNvPr id="22" name="TextBox 21"/>
+          <p:cNvSpPr txBox="1"/>
+          <p:nvPr/>
+        </p:nvSpPr>
+        <p:spPr>
+          <a:xfrm>
+            <a:off x="5074920" y="1600200"/>
+            <a:ext cx="2194560" cy="594360"/>
+          </a:xfrm>
+          <a:prstGeom prst="rect">
+            <a:avLst/>
+          </a:prstGeom>
+          <a:noFill/>
+        </p:spPr>
+        <p:txBody>
+          <a:bodyPr wrap="square">
+            <a:spAutoFit/>
+          </a:bodyPr>
+          <a:lstStyle/>
+          <a:p>
+            <a:pPr algn="ctr"/>
+            <a:r>
+              <a:rPr sz="2800" b="1" i="0">
+                <a:solidFill>
+                  <a:srgbClr val="D4A017"/>
+                </a:solidFill>
+                <a:latin typeface="Calibri"/>
+              </a:rPr>
+              <a:t>J3</a:t>
+            </a:r>
+          </a:p>
+        </p:txBody>
+      </p:sp>
+      <p:sp>
+        <p:nvSpPr>
+          <p:cNvPr id="23" name="TextBox 22"/>
+          <p:cNvSpPr txBox="1"/>
+          <p:nvPr/>
+        </p:nvSpPr>
+        <p:spPr>
+          <a:xfrm>
+            <a:off x="5166360" y="2240280"/>
+            <a:ext cx="2011680" cy="731520"/>
+          </a:xfrm>
+          <a:prstGeom prst="rect">
+            <a:avLst/>
+          </a:prstGeom>
+          <a:noFill/>
+        </p:spPr>
+        <p:txBody>
+          <a:bodyPr wrap="square">
+            <a:spAutoFit/>
+          </a:bodyPr>
+          <a:lstStyle/>
+          <a:p>
+            <a:pPr algn="ctr"/>
+            <a:r>
+              <a:rPr sz="1400" b="1" i="0">
+                <a:solidFill>
+                  <a:srgbClr val="008080"/>
+                </a:solidFill>
+                <a:latin typeface="Calibri"/>
+              </a:rPr>
+              <a:t>Analyse et Lecture du Script</a:t>
+            </a:r>
+          </a:p>
+        </p:txBody>
+      </p:sp>
+      <p:sp>
+        <p:nvSpPr>
+          <p:cNvPr id="24" name="TextBox 23"/>
+          <p:cNvSpPr txBox="1"/>
+          <p:nvPr/>
+        </p:nvSpPr>
+        <p:spPr>
+          <a:xfrm>
+            <a:off x="5166360" y="3063240"/>
+            <a:ext cx="2011680" cy="1097280"/>
+          </a:xfrm>
+          <a:prstGeom prst="rect">
+            <a:avLst/>
+          </a:prstGeom>
+          <a:noFill/>
+        </p:spPr>
+        <p:txBody>
+          <a:bodyPr wrap="square">
+            <a:spAutoFit/>
+          </a:bodyPr>
+          <a:lstStyle/>
+          <a:p>
+            <a:pPr algn="ctr"/>
+            <a:r>
+              <a:rPr sz="1300" b="0" i="0">
+                <a:solidFill>
+                  <a:srgbClr val="1A1A1A"/>
+                </a:solidFill>
+                <a:latin typeface="Calibri"/>
+              </a:rPr>
+              <a:t>9h30 – 17h30
+6h40 production
+effective</a:t>
+            </a:r>
+          </a:p>
+        </p:txBody>
+      </p:sp>
+      <p:sp>
+        <p:nvSpPr>
+          <p:cNvPr id="25" name="TextBox 24"/>
+          <p:cNvSpPr txBox="1"/>
+          <p:nvPr/>
+        </p:nvSpPr>
+        <p:spPr>
+          <a:xfrm>
+            <a:off x="5166360" y="4251960"/>
+            <a:ext cx="2011680" cy="1097280"/>
+          </a:xfrm>
+          <a:prstGeom prst="rect">
+            <a:avLst/>
+          </a:prstGeom>
+          <a:noFill/>
+        </p:spPr>
+        <p:txBody>
+          <a:bodyPr wrap="square">
+            <a:spAutoFit/>
+          </a:bodyPr>
+          <a:lstStyle/>
+          <a:p>
+            <a:pPr algn="ctr"/>
+            <a:r>
+              <a:rPr sz="1200" b="0" i="1">
+                <a:solidFill>
+                  <a:srgbClr val="555555"/>
+                </a:solidFill>
+                <a:latin typeface="Calibri"/>
+              </a:rPr>
+              <a:t>Pause 11h00
+Déjeuner 13h
+Pause 15h30</a:t>
+            </a:r>
+          </a:p>
+        </p:txBody>
+      </p:sp>
+      <p:sp>
+        <p:nvSpPr>
+          <p:cNvPr id="26" name="Rectangle 25"/>
+          <p:cNvSpPr/>
+          <p:nvPr/>
+        </p:nvSpPr>
+        <p:spPr>
+          <a:xfrm>
+            <a:off x="7452360" y="1600200"/>
+            <a:ext cx="2194560" cy="4389120"/>
+          </a:xfrm>
+          <a:prstGeom prst="rect">
+            <a:avLst/>
+          </a:prstGeom>
+          <a:solidFill>
+            <a:srgbClr val="FFFFFF"/>
+          </a:solidFill>
+          <a:ln>
+            <a:noFill/>
+          </a:ln>
+        </p:spPr>
+        <p:style>
+          <a:lnRef idx="1">
+            <a:schemeClr val="accent1"/>
+          </a:lnRef>
+          <a:fillRef idx="3">
+            <a:schemeClr val="accent1"/>
+          </a:fillRef>
+          <a:effectRef idx="2">
+            <a:schemeClr val="accent1"/>
+          </a:effectRef>
+          <a:fontRef idx="minor">
+            <a:schemeClr val="lt1"/>
+          </a:fontRef>
+        </p:style>
+        <p:txBody>
+          <a:bodyPr rtlCol="0" anchor="ctr"/>
+          <a:lstStyle/>
+          <a:p>
+            <a:pPr algn="ctr"/>
+          </a:p>
+        </p:txBody>
+      </p:sp>
+      <p:sp>
+        <p:nvSpPr>
+          <p:cNvPr id="27" name="Rectangle 26"/>
+          <p:cNvSpPr/>
+          <p:nvPr/>
+        </p:nvSpPr>
+        <p:spPr>
+          <a:xfrm>
+            <a:off x="7452360" y="1600200"/>
+            <a:ext cx="2194560" cy="594360"/>
+          </a:xfrm>
+          <a:prstGeom prst="rect">
+            <a:avLst/>
+          </a:prstGeom>
+          <a:solidFill>
+            <a:srgbClr val="008080"/>
+          </a:solidFill>
+          <a:ln>
+            <a:noFill/>
+          </a:ln>
+        </p:spPr>
+        <p:style>
+          <a:lnRef idx="1">
+            <a:schemeClr val="accent1"/>
+          </a:lnRef>
+          <a:fillRef idx="3">
+            <a:schemeClr val="accent1"/>
+          </a:fillRef>
+          <a:effectRef idx="2">
+            <a:schemeClr val="accent1"/>
+          </a:effectRef>
+          <a:fontRef idx="minor">
+            <a:schemeClr val="lt1"/>
+          </a:fontRef>
+        </p:style>
+        <p:txBody>
+          <a:bodyPr rtlCol="0" anchor="ctr"/>
+          <a:lstStyle/>
+          <a:p>
+            <a:pPr algn="ctr"/>
+          </a:p>
+        </p:txBody>
+      </p:sp>
+      <p:sp>
+        <p:nvSpPr>
+          <p:cNvPr id="28" name="TextBox 27"/>
+          <p:cNvSpPr txBox="1"/>
+          <p:nvPr/>
+        </p:nvSpPr>
+        <p:spPr>
+          <a:xfrm>
+            <a:off x="7452360" y="1600200"/>
+            <a:ext cx="2194560" cy="594360"/>
+          </a:xfrm>
+          <a:prstGeom prst="rect">
+            <a:avLst/>
+          </a:prstGeom>
+          <a:noFill/>
+        </p:spPr>
+        <p:txBody>
+          <a:bodyPr wrap="square">
+            <a:spAutoFit/>
+          </a:bodyPr>
+          <a:lstStyle/>
+          <a:p>
+            <a:pPr algn="ctr"/>
+            <a:r>
+              <a:rPr sz="2800" b="1" i="0">
+                <a:solidFill>
+                  <a:srgbClr val="D4A017"/>
+                </a:solidFill>
+                <a:latin typeface="Calibri"/>
+              </a:rPr>
+              <a:t>J4</a:t>
+            </a:r>
+          </a:p>
+        </p:txBody>
+      </p:sp>
+      <p:sp>
+        <p:nvSpPr>
+          <p:cNvPr id="29" name="TextBox 28"/>
+          <p:cNvSpPr txBox="1"/>
+          <p:nvPr/>
+        </p:nvSpPr>
+        <p:spPr>
+          <a:xfrm>
+            <a:off x="7543800" y="2240280"/>
+            <a:ext cx="2011680" cy="731520"/>
+          </a:xfrm>
+          <a:prstGeom prst="rect">
+            <a:avLst/>
+          </a:prstGeom>
+          <a:noFill/>
+        </p:spPr>
+        <p:txBody>
+          <a:bodyPr wrap="square">
+            <a:spAutoFit/>
+          </a:bodyPr>
+          <a:lstStyle/>
+          <a:p>
+            <a:pPr algn="ctr"/>
+            <a:r>
+              <a:rPr sz="1400" b="1" i="0">
+                <a:solidFill>
+                  <a:srgbClr val="008080"/>
+                </a:solidFill>
+                <a:latin typeface="Calibri"/>
+              </a:rPr>
+              <a:t>Traitement des Objections</a:t>
+            </a:r>
+          </a:p>
+        </p:txBody>
+      </p:sp>
+      <p:sp>
+        <p:nvSpPr>
+          <p:cNvPr id="30" name="TextBox 29"/>
+          <p:cNvSpPr txBox="1"/>
+          <p:nvPr/>
+        </p:nvSpPr>
+        <p:spPr>
+          <a:xfrm>
+            <a:off x="7543800" y="3063240"/>
+            <a:ext cx="2011680" cy="1097280"/>
+          </a:xfrm>
+          <a:prstGeom prst="rect">
+            <a:avLst/>
+          </a:prstGeom>
+          <a:noFill/>
+        </p:spPr>
+        <p:txBody>
+          <a:bodyPr wrap="square">
+            <a:spAutoFit/>
+          </a:bodyPr>
+          <a:lstStyle/>
+          <a:p>
+            <a:pPr algn="ctr"/>
+            <a:r>
+              <a:rPr sz="1300" b="0" i="0">
+                <a:solidFill>
+                  <a:srgbClr val="1A1A1A"/>
+                </a:solidFill>
+                <a:latin typeface="Calibri"/>
+              </a:rPr>
+              <a:t>9h30 – 17h30
+6h40 production
+effective</a:t>
+            </a:r>
+          </a:p>
+        </p:txBody>
+      </p:sp>
+      <p:sp>
+        <p:nvSpPr>
+          <p:cNvPr id="31" name="TextBox 30"/>
+          <p:cNvSpPr txBox="1"/>
+          <p:nvPr/>
+        </p:nvSpPr>
+        <p:spPr>
+          <a:xfrm>
+            <a:off x="7543800" y="4251960"/>
+            <a:ext cx="2011680" cy="1097280"/>
+          </a:xfrm>
+          <a:prstGeom prst="rect">
+            <a:avLst/>
+          </a:prstGeom>
+          <a:noFill/>
+        </p:spPr>
+        <p:txBody>
+          <a:bodyPr wrap="square">
+            <a:spAutoFit/>
+          </a:bodyPr>
+          <a:lstStyle/>
+          <a:p>
+            <a:pPr algn="ctr"/>
+            <a:r>
+              <a:rPr sz="1200" b="0" i="1">
+                <a:solidFill>
+                  <a:srgbClr val="555555"/>
+                </a:solidFill>
+                <a:latin typeface="Calibri"/>
+              </a:rPr>
+              <a:t>Pause 11h00
+Déjeuner 13h
+Pause 15h30</a:t>
+            </a:r>
+          </a:p>
+        </p:txBody>
+      </p:sp>
+      <p:sp>
+        <p:nvSpPr>
+          <p:cNvPr id="32" name="Rectangle 31"/>
+          <p:cNvSpPr/>
+          <p:nvPr/>
+        </p:nvSpPr>
+        <p:spPr>
+          <a:xfrm>
+            <a:off x="9829800" y="1600200"/>
+            <a:ext cx="2194560" cy="4389120"/>
+          </a:xfrm>
+          <a:prstGeom prst="rect">
+            <a:avLst/>
+          </a:prstGeom>
+          <a:solidFill>
+            <a:srgbClr val="FFFFFF"/>
+          </a:solidFill>
+          <a:ln>
+            <a:noFill/>
+          </a:ln>
+        </p:spPr>
+        <p:style>
+          <a:lnRef idx="1">
+            <a:schemeClr val="accent1"/>
+          </a:lnRef>
+          <a:fillRef idx="3">
+            <a:schemeClr val="accent1"/>
+          </a:fillRef>
+          <a:effectRef idx="2">
+            <a:schemeClr val="accent1"/>
+          </a:effectRef>
+          <a:fontRef idx="minor">
+            <a:schemeClr val="lt1"/>
+          </a:fontRef>
+        </p:style>
+        <p:txBody>
+          <a:bodyPr rtlCol="0" anchor="ctr"/>
+          <a:lstStyle/>
+          <a:p>
+            <a:pPr algn="ctr"/>
+          </a:p>
+        </p:txBody>
+      </p:sp>
+      <p:sp>
+        <p:nvSpPr>
+          <p:cNvPr id="33" name="Rectangle 32"/>
+          <p:cNvSpPr/>
+          <p:nvPr/>
+        </p:nvSpPr>
+        <p:spPr>
+          <a:xfrm>
+            <a:off x="9829800" y="1600200"/>
+            <a:ext cx="2194560" cy="594360"/>
+          </a:xfrm>
+          <a:prstGeom prst="rect">
+            <a:avLst/>
+          </a:prstGeom>
+          <a:solidFill>
+            <a:srgbClr val="008080"/>
+          </a:solidFill>
+          <a:ln>
+            <a:noFill/>
+          </a:ln>
+        </p:spPr>
+        <p:style>
+          <a:lnRef idx="1">
+            <a:schemeClr val="accent1"/>
+          </a:lnRef>
+          <a:fillRef idx="3">
+            <a:schemeClr val="accent1"/>
+          </a:fillRef>
+          <a:effectRef idx="2">
+            <a:schemeClr val="accent1"/>
+          </a:effectRef>
+          <a:fontRef idx="minor">
+            <a:schemeClr val="lt1"/>
+          </a:fontRef>
+        </p:style>
+        <p:txBody>
+          <a:bodyPr rtlCol="0" anchor="ctr"/>
+          <a:lstStyle/>
+          <a:p>
+            <a:pPr algn="ctr"/>
+          </a:p>
+        </p:txBody>
+      </p:sp>
+      <p:sp>
+        <p:nvSpPr>
+          <p:cNvPr id="34" name="TextBox 33"/>
+          <p:cNvSpPr txBox="1"/>
+          <p:nvPr/>
+        </p:nvSpPr>
+        <p:spPr>
+          <a:xfrm>
+            <a:off x="9829800" y="1600200"/>
+            <a:ext cx="2194560" cy="594360"/>
+          </a:xfrm>
+          <a:prstGeom prst="rect">
+            <a:avLst/>
+          </a:prstGeom>
+          <a:noFill/>
+        </p:spPr>
+        <p:txBody>
+          <a:bodyPr wrap="square">
+            <a:spAutoFit/>
+          </a:bodyPr>
+          <a:lstStyle/>
+          <a:p>
+            <a:pPr algn="ctr"/>
+            <a:r>
+              <a:rPr sz="2800" b="1" i="0">
+                <a:solidFill>
+                  <a:srgbClr val="D4A017"/>
+                </a:solidFill>
+                <a:latin typeface="Calibri"/>
+              </a:rPr>
+              <a:t>J5</a:t>
+            </a:r>
+          </a:p>
+        </p:txBody>
+      </p:sp>
+      <p:sp>
+        <p:nvSpPr>
+          <p:cNvPr id="35" name="TextBox 34"/>
+          <p:cNvSpPr txBox="1"/>
+          <p:nvPr/>
+        </p:nvSpPr>
+        <p:spPr>
+          <a:xfrm>
+            <a:off x="9921240" y="2240280"/>
+            <a:ext cx="2011680" cy="731520"/>
+          </a:xfrm>
+          <a:prstGeom prst="rect">
+            <a:avLst/>
+          </a:prstGeom>
+          <a:noFill/>
+        </p:spPr>
+        <p:txBody>
+          <a:bodyPr wrap="square">
+            <a:spAutoFit/>
+          </a:bodyPr>
+          <a:lstStyle/>
+          <a:p>
+            <a:pPr algn="ctr"/>
+            <a:r>
+              <a:rPr sz="1400" b="1" i="0">
+                <a:solidFill>
+                  <a:srgbClr val="008080"/>
+                </a:solidFill>
+                <a:latin typeface="Calibri"/>
+              </a:rPr>
+              <a:t>Synthèse &amp; Simulations</a:t>
+            </a:r>
+          </a:p>
+        </p:txBody>
+      </p:sp>
+      <p:sp>
+        <p:nvSpPr>
+          <p:cNvPr id="36" name="TextBox 35"/>
+          <p:cNvSpPr txBox="1"/>
+          <p:nvPr/>
+        </p:nvSpPr>
+        <p:spPr>
+          <a:xfrm>
+            <a:off x="9921240" y="3063240"/>
+            <a:ext cx="2011680" cy="1097280"/>
+          </a:xfrm>
+          <a:prstGeom prst="rect">
+            <a:avLst/>
+          </a:prstGeom>
+          <a:noFill/>
+        </p:spPr>
+        <p:txBody>
+          <a:bodyPr wrap="square">
+            <a:spAutoFit/>
+          </a:bodyPr>
+          <a:lstStyle/>
+          <a:p>
+            <a:pPr algn="ctr"/>
+            <a:r>
+              <a:rPr sz="1300" b="0" i="0">
+                <a:solidFill>
+                  <a:srgbClr val="1A1A1A"/>
+                </a:solidFill>
+                <a:latin typeface="Calibri"/>
+              </a:rPr>
+              <a:t>9h30 – 17h30
+6h40 production
+effective</a:t>
+            </a:r>
+          </a:p>
+        </p:txBody>
+      </p:sp>
+      <p:sp>
+        <p:nvSpPr>
+          <p:cNvPr id="37" name="TextBox 36"/>
+          <p:cNvSpPr txBox="1"/>
+          <p:nvPr/>
+        </p:nvSpPr>
+        <p:spPr>
+          <a:xfrm>
+            <a:off x="9921240" y="4251960"/>
+            <a:ext cx="2011680" cy="1097280"/>
+          </a:xfrm>
+          <a:prstGeom prst="rect">
+            <a:avLst/>
+          </a:prstGeom>
+          <a:noFill/>
+        </p:spPr>
+        <p:txBody>
+          <a:bodyPr wrap="square">
+            <a:spAutoFit/>
+          </a:bodyPr>
+          <a:lstStyle/>
+          <a:p>
+            <a:pPr algn="ctr"/>
+            <a:r>
+              <a:rPr sz="1200" b="0" i="1">
+                <a:solidFill>
+                  <a:srgbClr val="555555"/>
+                </a:solidFill>
+                <a:latin typeface="Calibri"/>
+              </a:rPr>
+              <a:t>Pause 11h00
+Déjeuner 13h
+Pause 15h30</a:t>
+            </a:r>
+          </a:p>
+        </p:txBody>
+      </p:sp>
+      <p:sp>
+        <p:nvSpPr>
+          <p:cNvPr id="38" name="Rectangle 37"/>
+          <p:cNvSpPr/>
+          <p:nvPr/>
+        </p:nvSpPr>
+        <p:spPr>
+          <a:xfrm>
+            <a:off x="0" y="6309360"/>
+            <a:ext cx="12188952" cy="548640"/>
+          </a:xfrm>
+          <a:prstGeom prst="rect">
+            <a:avLst/>
+          </a:prstGeom>
+          <a:solidFill>
+            <a:srgbClr val="004D4D"/>
+          </a:solidFill>
+          <a:ln>
+            <a:noFill/>
+          </a:ln>
+        </p:spPr>
+        <p:style>
+          <a:lnRef idx="1">
+            <a:schemeClr val="accent1"/>
+          </a:lnRef>
+          <a:fillRef idx="3">
+            <a:schemeClr val="accent1"/>
+          </a:fillRef>
+          <a:effectRef idx="2">
+            <a:schemeClr val="accent1"/>
+          </a:effectRef>
+          <a:fontRef idx="minor">
+            <a:schemeClr val="lt1"/>
+          </a:fontRef>
+        </p:style>
+        <p:txBody>
+          <a:bodyPr rtlCol="0" anchor="ctr"/>
+          <a:lstStyle/>
+          <a:p>
+            <a:pPr algn="ctr"/>
+          </a:p>
+        </p:txBody>
+      </p:sp>
+      <p:sp>
+        <p:nvSpPr>
+          <p:cNvPr id="39" name="Rectangle 38"/>
+          <p:cNvSpPr/>
+          <p:nvPr/>
+        </p:nvSpPr>
+        <p:spPr>
+          <a:xfrm>
+            <a:off x="0" y="6309360"/>
+            <a:ext cx="12188952" cy="36576"/>
+          </a:xfrm>
+          <a:prstGeom prst="rect">
+            <a:avLst/>
+          </a:prstGeom>
+          <a:solidFill>
+            <a:srgbClr val="FF0000"/>
+          </a:solidFill>
+          <a:ln>
+            <a:noFill/>
+          </a:ln>
+        </p:spPr>
+        <p:style>
+          <a:lnRef idx="1">
+            <a:schemeClr val="accent1"/>
+          </a:lnRef>
+          <a:fillRef idx="3">
+            <a:schemeClr val="accent1"/>
+          </a:fillRef>
+          <a:effectRef idx="2">
+            <a:schemeClr val="accent1"/>
+          </a:effectRef>
+          <a:fontRef idx="minor">
+            <a:schemeClr val="lt1"/>
+          </a:fontRef>
+        </p:style>
+        <p:txBody>
+          <a:bodyPr rtlCol="0" anchor="ctr"/>
+          <a:lstStyle/>
+          <a:p>
+            <a:pPr algn="ctr"/>
+          </a:p>
+        </p:txBody>
+      </p:sp>
+      <p:sp>
+        <p:nvSpPr>
+          <p:cNvPr id="40" name="TextBox 39"/>
+          <p:cNvSpPr txBox="1"/>
+          <p:nvPr/>
+        </p:nvSpPr>
+        <p:spPr>
+          <a:xfrm>
+            <a:off x="182880" y="6327648"/>
+            <a:ext cx="11823192" cy="512064"/>
+          </a:xfrm>
+          <a:prstGeom prst="rect">
+            <a:avLst/>
+          </a:prstGeom>
+          <a:noFill/>
+        </p:spPr>
+        <p:txBody>
+          <a:bodyPr wrap="square">
+            <a:spAutoFit/>
+          </a:bodyPr>
+          <a:lstStyle/>
+          <a:p>
+            <a:pPr algn="ctr"/>
+            <a:r>
+              <a:rPr sz="800" b="0" i="0">
+                <a:solidFill>
+                  <a:srgbClr val="CCE5E5"/>
+                </a:solidFill>
+                <a:latin typeface="Calibri"/>
+              </a:rPr>
+              <a:t>⚠  DOCUMENT PROTÉGÉ — Toute modification, rectification ou ajout est STRICTEMENT INTERDIT. Seules la Direction Générale de SHY-Performance ou une personne expressément mandatée sont autorisées à modifier ce document.  Élaboré par Tamou Eljerrari — Ingénieur en Formation — Sur ordre de la Directrice Générale Mme Salima Negrao.</a:t>
             </a:r>
           </a:p>
         </p:txBody>
@@ -5302,13 +7175,13 @@
         <p:spPr>
           <a:xfrm>
             <a:off x="0" y="0"/>
-            <a:ext cx="12188952" cy="274320"/>
+            <a:ext cx="12188952" cy="73152"/>
           </a:xfrm>
           <a:prstGeom prst="rect">
             <a:avLst/>
           </a:prstGeom>
           <a:solidFill>
-            <a:srgbClr val="FFFFFF"/>
+            <a:srgbClr val="D4A017"/>
           </a:solidFill>
           <a:ln>
             <a:noFill/>
@@ -5344,14 +7217,14 @@
         </p:nvSpPr>
         <p:spPr>
           <a:xfrm>
-            <a:off x="0" y="6583680"/>
-            <a:ext cx="12188952" cy="274320"/>
+            <a:off x="0" y="6784848"/>
+            <a:ext cx="12188952" cy="73152"/>
           </a:xfrm>
           <a:prstGeom prst="rect">
             <a:avLst/>
           </a:prstGeom>
           <a:solidFill>
-            <a:srgbClr val="FFFFFF"/>
+            <a:srgbClr val="D4A017"/>
           </a:solidFill>
           <a:ln>
             <a:noFill/>
@@ -5379,16 +7252,40 @@
           </a:p>
         </p:txBody>
       </p:sp>
-      <p:sp>
-        <p:nvSpPr>
-          <p:cNvPr id="5" name="TextBox 4"/>
+      <p:pic>
+        <p:nvPicPr>
+          <p:cNvPr id="5" name="Picture 4" descr="shy_logo.png"/>
+          <p:cNvPicPr>
+            <a:picLocks noChangeAspect="1"/>
+          </p:cNvPicPr>
+          <p:nvPr/>
+        </p:nvPicPr>
+        <p:blipFill>
+          <a:blip r:embed="rId2"/>
+          <a:stretch>
+            <a:fillRect/>
+          </a:stretch>
+        </p:blipFill>
+        <p:spPr>
+          <a:xfrm>
+            <a:off x="457200" y="320040"/>
+            <a:ext cx="2481943" cy="1097280"/>
+          </a:xfrm>
+          <a:prstGeom prst="rect">
+            <a:avLst/>
+          </a:prstGeom>
+        </p:spPr>
+      </p:pic>
+      <p:sp>
+        <p:nvSpPr>
+          <p:cNvPr id="6" name="TextBox 5"/>
           <p:cNvSpPr txBox="1"/>
           <p:nvPr/>
         </p:nvSpPr>
         <p:spPr>
           <a:xfrm>
-            <a:off x="914400" y="1645920"/>
-            <a:ext cx="10332720" cy="1188720"/>
+            <a:off x="457200" y="2103120"/>
+            <a:ext cx="11247120" cy="1645920"/>
           </a:xfrm>
           <a:prstGeom prst="rect">
             <a:avLst/>
@@ -5403,7 +7300,7 @@
           <a:p>
             <a:pPr algn="ctr"/>
             <a:r>
-              <a:rPr sz="3800" b="1" i="0">
+              <a:rPr sz="5200" b="1" i="0">
                 <a:solidFill>
                   <a:srgbClr val="FFFFFF"/>
                 </a:solidFill>
@@ -5416,20 +7313,20 @@
       </p:sp>
       <p:sp>
         <p:nvSpPr>
-          <p:cNvPr id="6" name="Rectangle 5"/>
+          <p:cNvPr id="7" name="Rectangle 6"/>
           <p:cNvSpPr/>
           <p:nvPr/>
         </p:nvSpPr>
         <p:spPr>
           <a:xfrm>
-            <a:off x="2743200" y="2926080"/>
-            <a:ext cx="6675120" cy="54864"/>
+            <a:off x="1828800" y="3840480"/>
+            <a:ext cx="8531352" cy="54864"/>
           </a:xfrm>
           <a:prstGeom prst="rect">
             <a:avLst/>
           </a:prstGeom>
           <a:solidFill>
-            <a:srgbClr val="FFFFFF"/>
+            <a:srgbClr val="D4A017"/>
           </a:solidFill>
           <a:ln>
             <a:noFill/>
@@ -5459,14 +7356,14 @@
       </p:sp>
       <p:sp>
         <p:nvSpPr>
-          <p:cNvPr id="7" name="TextBox 6"/>
+          <p:cNvPr id="8" name="TextBox 7"/>
           <p:cNvSpPr txBox="1"/>
           <p:nvPr/>
         </p:nvSpPr>
         <p:spPr>
           <a:xfrm>
-            <a:off x="914400" y="3108960"/>
-            <a:ext cx="10332720" cy="548640"/>
+            <a:off x="457200" y="4023360"/>
+            <a:ext cx="11247120" cy="640080"/>
           </a:xfrm>
           <a:prstGeom prst="rect">
             <a:avLst/>
@@ -5481,13 +7378,169 @@
           <a:p>
             <a:pPr algn="ctr"/>
             <a:r>
-              <a:rPr sz="1800" b="0" i="0">
-                <a:solidFill>
-                  <a:srgbClr val="CCE5E5"/>
+              <a:rPr sz="2200" b="0" i="0">
+                <a:solidFill>
+                  <a:srgbClr val="D4A017"/>
                 </a:solidFill>
                 <a:latin typeface="Calibri"/>
               </a:rPr>
               <a:t>SHY-Performance  ×  FIDELIS  ×  UNICEF France</a:t>
+            </a:r>
+          </a:p>
+        </p:txBody>
+      </p:sp>
+      <p:sp>
+        <p:nvSpPr>
+          <p:cNvPr id="9" name="TextBox 8"/>
+          <p:cNvSpPr txBox="1"/>
+          <p:nvPr/>
+        </p:nvSpPr>
+        <p:spPr>
+          <a:xfrm>
+            <a:off x="457200" y="4663440"/>
+            <a:ext cx="11247120" cy="457200"/>
+          </a:xfrm>
+          <a:prstGeom prst="rect">
+            <a:avLst/>
+          </a:prstGeom>
+          <a:noFill/>
+        </p:spPr>
+        <p:txBody>
+          <a:bodyPr wrap="square">
+            <a:spAutoFit/>
+          </a:bodyPr>
+          <a:lstStyle/>
+          <a:p>
+            <a:pPr algn="ctr"/>
+            <a:r>
+              <a:rPr sz="1600" b="0" i="1">
+                <a:solidFill>
+                  <a:srgbClr val="CCE5E5"/>
+                </a:solidFill>
+                <a:latin typeface="Calibri"/>
+              </a:rPr>
+              <a:t>Fundraising · Formation · Performance</a:t>
+            </a:r>
+          </a:p>
+        </p:txBody>
+      </p:sp>
+      <p:sp>
+        <p:nvSpPr>
+          <p:cNvPr id="10" name="Rectangle 9"/>
+          <p:cNvSpPr/>
+          <p:nvPr/>
+        </p:nvSpPr>
+        <p:spPr>
+          <a:xfrm>
+            <a:off x="0" y="6309360"/>
+            <a:ext cx="12188952" cy="548640"/>
+          </a:xfrm>
+          <a:prstGeom prst="rect">
+            <a:avLst/>
+          </a:prstGeom>
+          <a:solidFill>
+            <a:srgbClr val="004D4D"/>
+          </a:solidFill>
+          <a:ln>
+            <a:noFill/>
+          </a:ln>
+        </p:spPr>
+        <p:style>
+          <a:lnRef idx="1">
+            <a:schemeClr val="accent1"/>
+          </a:lnRef>
+          <a:fillRef idx="3">
+            <a:schemeClr val="accent1"/>
+          </a:fillRef>
+          <a:effectRef idx="2">
+            <a:schemeClr val="accent1"/>
+          </a:effectRef>
+          <a:fontRef idx="minor">
+            <a:schemeClr val="lt1"/>
+          </a:fontRef>
+        </p:style>
+        <p:txBody>
+          <a:bodyPr rtlCol="0" anchor="ctr"/>
+          <a:lstStyle/>
+          <a:p>
+            <a:pPr algn="ctr"/>
+          </a:p>
+        </p:txBody>
+      </p:sp>
+      <p:sp>
+        <p:nvSpPr>
+          <p:cNvPr id="11" name="Rectangle 10"/>
+          <p:cNvSpPr/>
+          <p:nvPr/>
+        </p:nvSpPr>
+        <p:spPr>
+          <a:xfrm>
+            <a:off x="0" y="6309360"/>
+            <a:ext cx="12188952" cy="36576"/>
+          </a:xfrm>
+          <a:prstGeom prst="rect">
+            <a:avLst/>
+          </a:prstGeom>
+          <a:solidFill>
+            <a:srgbClr val="FF0000"/>
+          </a:solidFill>
+          <a:ln>
+            <a:noFill/>
+          </a:ln>
+        </p:spPr>
+        <p:style>
+          <a:lnRef idx="1">
+            <a:schemeClr val="accent1"/>
+          </a:lnRef>
+          <a:fillRef idx="3">
+            <a:schemeClr val="accent1"/>
+          </a:fillRef>
+          <a:effectRef idx="2">
+            <a:schemeClr val="accent1"/>
+          </a:effectRef>
+          <a:fontRef idx="minor">
+            <a:schemeClr val="lt1"/>
+          </a:fontRef>
+        </p:style>
+        <p:txBody>
+          <a:bodyPr rtlCol="0" anchor="ctr"/>
+          <a:lstStyle/>
+          <a:p>
+            <a:pPr algn="ctr"/>
+          </a:p>
+        </p:txBody>
+      </p:sp>
+      <p:sp>
+        <p:nvSpPr>
+          <p:cNvPr id="12" name="TextBox 11"/>
+          <p:cNvSpPr txBox="1"/>
+          <p:nvPr/>
+        </p:nvSpPr>
+        <p:spPr>
+          <a:xfrm>
+            <a:off x="182880" y="6327648"/>
+            <a:ext cx="11823192" cy="512064"/>
+          </a:xfrm>
+          <a:prstGeom prst="rect">
+            <a:avLst/>
+          </a:prstGeom>
+          <a:noFill/>
+        </p:spPr>
+        <p:txBody>
+          <a:bodyPr wrap="square">
+            <a:spAutoFit/>
+          </a:bodyPr>
+          <a:lstStyle/>
+          <a:p>
+            <a:pPr algn="ctr"/>
+            <a:r>
+              <a:rPr sz="800" b="0" i="0">
+                <a:solidFill>
+                  <a:srgbClr val="CCE5E5"/>
+                </a:solidFill>
+                <a:latin typeface="Calibri"/>
+              </a:rPr>
+              <a:t>⚠  DOCUMENT PROTÉGÉ — Toute modification, rectification ou ajout est STRICTEMENT INTERDIT. Seules la Direction Générale de SHY-Performance ou une personne expressément mandatée sont autorisées à modifier ce document.  Élaboré par Tamou Eljerrari — Ingénieur en Formation — Sur ordre de la Directrice Générale Mme Salima Negrao.</a:t>
             </a:r>
           </a:p>
         </p:txBody>

</xml_diff>

<commit_message>
feat: logo SHY-Performance prominent sur slide 1 et dernière slide de chaque module
- Cover (slide 1): logo compact shy_logo.png visible dans panneau gauche + panneau droit (centré, grande taille)
- Slides Merci/Félicitations (dernière slide): logo compact centré en grand format
- add_logo_cover() et add_logo_last() : nouvelles fonctions dédiées
- 7 modules régénérés (81 slides) — design validé

https://claude.ai/code/session_019GY1Nt6aASgMoHXKsDdGTr
</commit_message>
<xml_diff>
--- a/FIM_Book0_FileConducteur.pptx
+++ b/FIM_Book0_FileConducteur.pptx
@@ -3225,7 +3225,7 @@
       </p:sp>
       <p:pic>
         <p:nvPicPr>
-          <p:cNvPr id="5" name="Picture 4" descr="shy_logo_v2.png"/>
+          <p:cNvPr id="5" name="Picture 4" descr="shy_logo.png"/>
           <p:cNvPicPr>
             <a:picLocks noChangeAspect="1"/>
           </p:cNvPicPr>
@@ -3240,7 +3240,7 @@
         <p:spPr>
           <a:xfrm>
             <a:off x="274320" y="548640"/>
-            <a:ext cx="1124321" cy="1097280"/>
+            <a:ext cx="2275114" cy="1005840"/>
           </a:xfrm>
           <a:prstGeom prst="rect">
             <a:avLst/>
@@ -3673,9 +3673,33 @@
           </a:p>
         </p:txBody>
       </p:sp>
-      <p:sp>
-        <p:nvSpPr>
-          <p:cNvPr id="17" name="Rectangle 16"/>
+      <p:pic>
+        <p:nvPicPr>
+          <p:cNvPr id="17" name="Picture 16" descr="shy_logo.png"/>
+          <p:cNvPicPr>
+            <a:picLocks noChangeAspect="1"/>
+          </p:cNvPicPr>
+          <p:nvPr/>
+        </p:nvPicPr>
+        <p:blipFill>
+          <a:blip r:embed="rId2"/>
+          <a:stretch>
+            <a:fillRect/>
+          </a:stretch>
+        </p:blipFill>
+        <p:spPr>
+          <a:xfrm>
+            <a:off x="7024115" y="5212080"/>
+            <a:ext cx="2895600" cy="1280160"/>
+          </a:xfrm>
+          <a:prstGeom prst="rect">
+            <a:avLst/>
+          </a:prstGeom>
+        </p:spPr>
+      </p:pic>
+      <p:sp>
+        <p:nvSpPr>
+          <p:cNvPr id="18" name="Rectangle 17"/>
           <p:cNvSpPr/>
           <p:nvPr/>
         </p:nvSpPr>
@@ -3718,7 +3742,7 @@
       </p:sp>
       <p:sp>
         <p:nvSpPr>
-          <p:cNvPr id="18" name="Rectangle 17"/>
+          <p:cNvPr id="19" name="Rectangle 18"/>
           <p:cNvSpPr/>
           <p:nvPr/>
         </p:nvSpPr>
@@ -3761,7 +3785,7 @@
       </p:sp>
       <p:sp>
         <p:nvSpPr>
-          <p:cNvPr id="19" name="TextBox 18"/>
+          <p:cNvPr id="20" name="TextBox 19"/>
           <p:cNvSpPr txBox="1"/>
           <p:nvPr/>
         </p:nvSpPr>
@@ -14555,7 +14579,7 @@
       </p:sp>
       <p:pic>
         <p:nvPicPr>
-          <p:cNvPr id="10" name="Picture 9" descr="shy_logo_v2.png"/>
+          <p:cNvPr id="10" name="Picture 9" descr="shy_logo.png"/>
           <p:cNvPicPr>
             <a:picLocks noChangeAspect="1"/>
           </p:cNvPicPr>
@@ -14569,8 +14593,8 @@
         </p:blipFill>
         <p:spPr>
           <a:xfrm>
-            <a:off x="5303520" y="5394960"/>
-            <a:ext cx="1030628" cy="1005840"/>
+            <a:off x="4439847" y="5029200"/>
+            <a:ext cx="3309257" cy="1463040"/>
           </a:xfrm>
           <a:prstGeom prst="rect">
             <a:avLst/>

</xml_diff>